<commit_message>
Generalized analytic ditch by allowing dtich points to be anywhere at the top left side or bottom of the aquifer when using the sin-transformation.
</commit_message>
<xml_diff>
--- a/Projects/GGOR/doc/images/GGORimages.pptx
+++ b/Projects/GGOR/doc/images/GGORimages.pptx
@@ -9,9 +9,10 @@
     <p:sldId id="260" r:id="rId3"/>
     <p:sldId id="261" r:id="rId4"/>
     <p:sldId id="262" r:id="rId5"/>
-    <p:sldId id="259" r:id="rId6"/>
-    <p:sldId id="258" r:id="rId7"/>
-    <p:sldId id="257" r:id="rId8"/>
+    <p:sldId id="263" r:id="rId6"/>
+    <p:sldId id="259" r:id="rId7"/>
+    <p:sldId id="258" r:id="rId8"/>
+    <p:sldId id="257" r:id="rId9"/>
   </p:sldIdLst>
   <p:sldSz cx="9144000" cy="6858000" type="screen4x3"/>
   <p:notesSz cx="6858000" cy="9144000"/>
@@ -308,7 +309,7 @@
           <a:p>
             <a:fld id="{0D031B3D-0308-F34E-8F0A-F36FA1DD3C8F}" type="datetimeFigureOut">
               <a:rPr lang="en-US" smtClean="0"/>
-              <a:t>12/23/25</a:t>
+              <a:t>1/2/26</a:t>
             </a:fld>
             <a:endParaRPr lang="en-US"/>
           </a:p>
@@ -476,7 +477,7 @@
           <a:p>
             <a:fld id="{0D031B3D-0308-F34E-8F0A-F36FA1DD3C8F}" type="datetimeFigureOut">
               <a:rPr lang="en-US" smtClean="0"/>
-              <a:t>12/23/25</a:t>
+              <a:t>1/2/26</a:t>
             </a:fld>
             <a:endParaRPr lang="en-US"/>
           </a:p>
@@ -654,7 +655,7 @@
           <a:p>
             <a:fld id="{0D031B3D-0308-F34E-8F0A-F36FA1DD3C8F}" type="datetimeFigureOut">
               <a:rPr lang="en-US" smtClean="0"/>
-              <a:t>12/23/25</a:t>
+              <a:t>1/2/26</a:t>
             </a:fld>
             <a:endParaRPr lang="en-US"/>
           </a:p>
@@ -822,7 +823,7 @@
           <a:p>
             <a:fld id="{0D031B3D-0308-F34E-8F0A-F36FA1DD3C8F}" type="datetimeFigureOut">
               <a:rPr lang="en-US" smtClean="0"/>
-              <a:t>12/23/25</a:t>
+              <a:t>1/2/26</a:t>
             </a:fld>
             <a:endParaRPr lang="en-US"/>
           </a:p>
@@ -1067,7 +1068,7 @@
           <a:p>
             <a:fld id="{0D031B3D-0308-F34E-8F0A-F36FA1DD3C8F}" type="datetimeFigureOut">
               <a:rPr lang="en-US" smtClean="0"/>
-              <a:t>12/23/25</a:t>
+              <a:t>1/2/26</a:t>
             </a:fld>
             <a:endParaRPr lang="en-US"/>
           </a:p>
@@ -1352,7 +1353,7 @@
           <a:p>
             <a:fld id="{0D031B3D-0308-F34E-8F0A-F36FA1DD3C8F}" type="datetimeFigureOut">
               <a:rPr lang="en-US" smtClean="0"/>
-              <a:t>12/23/25</a:t>
+              <a:t>1/2/26</a:t>
             </a:fld>
             <a:endParaRPr lang="en-US"/>
           </a:p>
@@ -1771,7 +1772,7 @@
           <a:p>
             <a:fld id="{0D031B3D-0308-F34E-8F0A-F36FA1DD3C8F}" type="datetimeFigureOut">
               <a:rPr lang="en-US" smtClean="0"/>
-              <a:t>12/23/25</a:t>
+              <a:t>1/2/26</a:t>
             </a:fld>
             <a:endParaRPr lang="en-US"/>
           </a:p>
@@ -1888,7 +1889,7 @@
           <a:p>
             <a:fld id="{0D031B3D-0308-F34E-8F0A-F36FA1DD3C8F}" type="datetimeFigureOut">
               <a:rPr lang="en-US" smtClean="0"/>
-              <a:t>12/23/25</a:t>
+              <a:t>1/2/26</a:t>
             </a:fld>
             <a:endParaRPr lang="en-US"/>
           </a:p>
@@ -1983,7 +1984,7 @@
           <a:p>
             <a:fld id="{0D031B3D-0308-F34E-8F0A-F36FA1DD3C8F}" type="datetimeFigureOut">
               <a:rPr lang="en-US" smtClean="0"/>
-              <a:t>12/23/25</a:t>
+              <a:t>1/2/26</a:t>
             </a:fld>
             <a:endParaRPr lang="en-US"/>
           </a:p>
@@ -2258,7 +2259,7 @@
           <a:p>
             <a:fld id="{0D031B3D-0308-F34E-8F0A-F36FA1DD3C8F}" type="datetimeFigureOut">
               <a:rPr lang="en-US" smtClean="0"/>
-              <a:t>12/23/25</a:t>
+              <a:t>1/2/26</a:t>
             </a:fld>
             <a:endParaRPr lang="en-US"/>
           </a:p>
@@ -2510,7 +2511,7 @@
           <a:p>
             <a:fld id="{0D031B3D-0308-F34E-8F0A-F36FA1DD3C8F}" type="datetimeFigureOut">
               <a:rPr lang="en-US" smtClean="0"/>
-              <a:t>12/23/25</a:t>
+              <a:t>1/2/26</a:t>
             </a:fld>
             <a:endParaRPr lang="en-US"/>
           </a:p>
@@ -2721,7 +2722,7 @@
           <a:p>
             <a:fld id="{0D031B3D-0308-F34E-8F0A-F36FA1DD3C8F}" type="datetimeFigureOut">
               <a:rPr lang="en-US" smtClean="0"/>
-              <a:t>12/23/25</a:t>
+              <a:t>1/2/26</a:t>
             </a:fld>
             <a:endParaRPr lang="en-US"/>
           </a:p>
@@ -5806,6 +5807,2328 @@
   <p:cSld>
     <p:spTree>
       <p:nvGrpSpPr>
+        <p:cNvPr id="1" name="">
+          <a:extLst>
+            <a:ext uri="{FF2B5EF4-FFF2-40B4-BE49-F238E27FC236}">
+              <a16:creationId xmlns:a16="http://schemas.microsoft.com/office/drawing/2014/main" id="{D684BC55-19AF-D4DB-937B-7406C7029B00}"/>
+            </a:ext>
+          </a:extLst>
+        </p:cNvPr>
+        <p:cNvGrpSpPr/>
+        <p:nvPr/>
+      </p:nvGrpSpPr>
+      <p:grpSpPr>
+        <a:xfrm>
+          <a:off x="0" y="0"/>
+          <a:ext cx="0" cy="0"/>
+          <a:chOff x="0" y="0"/>
+          <a:chExt cx="0" cy="0"/>
+        </a:xfrm>
+      </p:grpSpPr>
+      <p:grpSp>
+        <p:nvGrpSpPr>
+          <p:cNvPr id="49" name="Group 48">
+            <a:extLst>
+              <a:ext uri="{FF2B5EF4-FFF2-40B4-BE49-F238E27FC236}">
+                <a16:creationId xmlns:a16="http://schemas.microsoft.com/office/drawing/2014/main" id="{794C1E8B-AA1E-7082-99D8-FBD0840FD1C2}"/>
+              </a:ext>
+            </a:extLst>
+          </p:cNvPr>
+          <p:cNvGrpSpPr/>
+          <p:nvPr/>
+        </p:nvGrpSpPr>
+        <p:grpSpPr>
+          <a:xfrm>
+            <a:off x="1585290" y="356260"/>
+            <a:ext cx="5686871" cy="5584715"/>
+            <a:chOff x="1585290" y="356260"/>
+            <a:chExt cx="5686871" cy="5584715"/>
+          </a:xfrm>
+        </p:grpSpPr>
+        <p:cxnSp>
+          <p:nvCxnSpPr>
+            <p:cNvPr id="3" name="Straight Connector 2">
+              <a:extLst>
+                <a:ext uri="{FF2B5EF4-FFF2-40B4-BE49-F238E27FC236}">
+                  <a16:creationId xmlns:a16="http://schemas.microsoft.com/office/drawing/2014/main" id="{04E65E7E-299B-E273-3A16-38378C24F626}"/>
+                </a:ext>
+              </a:extLst>
+            </p:cNvPr>
+            <p:cNvCxnSpPr>
+              <a:cxnSpLocks/>
+            </p:cNvCxnSpPr>
+            <p:nvPr/>
+          </p:nvCxnSpPr>
+          <p:spPr>
+            <a:xfrm>
+              <a:off x="1610139" y="1449168"/>
+              <a:ext cx="1958009" cy="0"/>
+            </a:xfrm>
+            <a:prstGeom prst="line">
+              <a:avLst/>
+            </a:prstGeom>
+          </p:spPr>
+          <p:style>
+            <a:lnRef idx="2">
+              <a:schemeClr val="accent1"/>
+            </a:lnRef>
+            <a:fillRef idx="0">
+              <a:schemeClr val="accent1"/>
+            </a:fillRef>
+            <a:effectRef idx="1">
+              <a:schemeClr val="accent1"/>
+            </a:effectRef>
+            <a:fontRef idx="minor">
+              <a:schemeClr val="tx1"/>
+            </a:fontRef>
+          </p:style>
+        </p:cxnSp>
+        <p:sp>
+          <p:nvSpPr>
+            <p:cNvPr id="7" name="Freeform 6">
+              <a:extLst>
+                <a:ext uri="{FF2B5EF4-FFF2-40B4-BE49-F238E27FC236}">
+                  <a16:creationId xmlns:a16="http://schemas.microsoft.com/office/drawing/2014/main" id="{A39AE47F-A720-50FE-5140-9C9EEED8254A}"/>
+                </a:ext>
+              </a:extLst>
+            </p:cNvPr>
+            <p:cNvSpPr/>
+            <p:nvPr/>
+          </p:nvSpPr>
+          <p:spPr>
+            <a:xfrm>
+              <a:off x="3568148" y="1455480"/>
+              <a:ext cx="1570382" cy="302962"/>
+            </a:xfrm>
+            <a:custGeom>
+              <a:avLst/>
+              <a:gdLst>
+                <a:gd name="csX0" fmla="*/ 0 w 1570382"/>
+                <a:gd name="csY0" fmla="*/ 0 h 477079"/>
+                <a:gd name="csX1" fmla="*/ 0 w 1570382"/>
+                <a:gd name="csY1" fmla="*/ 0 h 477079"/>
+                <a:gd name="csX2" fmla="*/ 9939 w 1570382"/>
+                <a:gd name="csY2" fmla="*/ 99392 h 477079"/>
+                <a:gd name="csX3" fmla="*/ 29817 w 1570382"/>
+                <a:gd name="csY3" fmla="*/ 149087 h 477079"/>
+                <a:gd name="csX4" fmla="*/ 69574 w 1570382"/>
+                <a:gd name="csY4" fmla="*/ 218661 h 477079"/>
+                <a:gd name="csX5" fmla="*/ 129209 w 1570382"/>
+                <a:gd name="csY5" fmla="*/ 288235 h 477079"/>
+                <a:gd name="csX6" fmla="*/ 178904 w 1570382"/>
+                <a:gd name="csY6" fmla="*/ 298174 h 477079"/>
+                <a:gd name="csX7" fmla="*/ 208722 w 1570382"/>
+                <a:gd name="csY7" fmla="*/ 308113 h 477079"/>
+                <a:gd name="csX8" fmla="*/ 327991 w 1570382"/>
+                <a:gd name="csY8" fmla="*/ 327992 h 477079"/>
+                <a:gd name="csX9" fmla="*/ 357809 w 1570382"/>
+                <a:gd name="csY9" fmla="*/ 357809 h 477079"/>
+                <a:gd name="csX10" fmla="*/ 367748 w 1570382"/>
+                <a:gd name="csY10" fmla="*/ 387626 h 477079"/>
+                <a:gd name="csX11" fmla="*/ 407504 w 1570382"/>
+                <a:gd name="csY11" fmla="*/ 397566 h 477079"/>
+                <a:gd name="csX12" fmla="*/ 437322 w 1570382"/>
+                <a:gd name="csY12" fmla="*/ 407505 h 477079"/>
+                <a:gd name="csX13" fmla="*/ 496956 w 1570382"/>
+                <a:gd name="csY13" fmla="*/ 417444 h 477079"/>
+                <a:gd name="csX14" fmla="*/ 556591 w 1570382"/>
+                <a:gd name="csY14" fmla="*/ 437322 h 477079"/>
+                <a:gd name="csX15" fmla="*/ 586409 w 1570382"/>
+                <a:gd name="csY15" fmla="*/ 467140 h 477079"/>
+                <a:gd name="csX16" fmla="*/ 616226 w 1570382"/>
+                <a:gd name="csY16" fmla="*/ 477079 h 477079"/>
+                <a:gd name="csX17" fmla="*/ 785191 w 1570382"/>
+                <a:gd name="csY17" fmla="*/ 467140 h 477079"/>
+                <a:gd name="csX18" fmla="*/ 815009 w 1570382"/>
+                <a:gd name="csY18" fmla="*/ 457200 h 477079"/>
+                <a:gd name="csX19" fmla="*/ 954156 w 1570382"/>
+                <a:gd name="csY19" fmla="*/ 427383 h 477079"/>
+                <a:gd name="csX20" fmla="*/ 1003852 w 1570382"/>
+                <a:gd name="csY20" fmla="*/ 417444 h 477079"/>
+                <a:gd name="csX21" fmla="*/ 1093304 w 1570382"/>
+                <a:gd name="csY21" fmla="*/ 387626 h 477079"/>
+                <a:gd name="csX22" fmla="*/ 1123122 w 1570382"/>
+                <a:gd name="csY22" fmla="*/ 377687 h 477079"/>
+                <a:gd name="csX23" fmla="*/ 1152939 w 1570382"/>
+                <a:gd name="csY23" fmla="*/ 367748 h 477079"/>
+                <a:gd name="csX24" fmla="*/ 1212574 w 1570382"/>
+                <a:gd name="csY24" fmla="*/ 357809 h 477079"/>
+                <a:gd name="csX25" fmla="*/ 1242391 w 1570382"/>
+                <a:gd name="csY25" fmla="*/ 347870 h 477079"/>
+                <a:gd name="csX26" fmla="*/ 1262269 w 1570382"/>
+                <a:gd name="csY26" fmla="*/ 318053 h 477079"/>
+                <a:gd name="csX27" fmla="*/ 1282148 w 1570382"/>
+                <a:gd name="csY27" fmla="*/ 298174 h 477079"/>
+                <a:gd name="csX28" fmla="*/ 1302026 w 1570382"/>
+                <a:gd name="csY28" fmla="*/ 268357 h 477079"/>
+                <a:gd name="csX29" fmla="*/ 1331843 w 1570382"/>
+                <a:gd name="csY29" fmla="*/ 248479 h 477079"/>
+                <a:gd name="csX30" fmla="*/ 1351722 w 1570382"/>
+                <a:gd name="csY30" fmla="*/ 228600 h 477079"/>
+                <a:gd name="csX31" fmla="*/ 1391478 w 1570382"/>
+                <a:gd name="csY31" fmla="*/ 218661 h 477079"/>
+                <a:gd name="csX32" fmla="*/ 1451113 w 1570382"/>
+                <a:gd name="csY32" fmla="*/ 198783 h 477079"/>
+                <a:gd name="csX33" fmla="*/ 1480930 w 1570382"/>
+                <a:gd name="csY33" fmla="*/ 188844 h 477079"/>
+                <a:gd name="csX34" fmla="*/ 1520687 w 1570382"/>
+                <a:gd name="csY34" fmla="*/ 178905 h 477079"/>
+                <a:gd name="csX35" fmla="*/ 1540565 w 1570382"/>
+                <a:gd name="csY35" fmla="*/ 159026 h 477079"/>
+                <a:gd name="csX36" fmla="*/ 1560443 w 1570382"/>
+                <a:gd name="csY36" fmla="*/ 99392 h 477079"/>
+                <a:gd name="csX37" fmla="*/ 1570382 w 1570382"/>
+                <a:gd name="csY37" fmla="*/ 69574 h 477079"/>
+                <a:gd name="csX38" fmla="*/ 1570382 w 1570382"/>
+                <a:gd name="csY38" fmla="*/ 19879 h 477079"/>
+              </a:gdLst>
+              <a:ahLst/>
+              <a:cxnLst>
+                <a:cxn ang="0">
+                  <a:pos x="csX0" y="csY0"/>
+                </a:cxn>
+                <a:cxn ang="0">
+                  <a:pos x="csX1" y="csY1"/>
+                </a:cxn>
+                <a:cxn ang="0">
+                  <a:pos x="csX2" y="csY2"/>
+                </a:cxn>
+                <a:cxn ang="0">
+                  <a:pos x="csX3" y="csY3"/>
+                </a:cxn>
+                <a:cxn ang="0">
+                  <a:pos x="csX4" y="csY4"/>
+                </a:cxn>
+                <a:cxn ang="0">
+                  <a:pos x="csX5" y="csY5"/>
+                </a:cxn>
+                <a:cxn ang="0">
+                  <a:pos x="csX6" y="csY6"/>
+                </a:cxn>
+                <a:cxn ang="0">
+                  <a:pos x="csX7" y="csY7"/>
+                </a:cxn>
+                <a:cxn ang="0">
+                  <a:pos x="csX8" y="csY8"/>
+                </a:cxn>
+                <a:cxn ang="0">
+                  <a:pos x="csX9" y="csY9"/>
+                </a:cxn>
+                <a:cxn ang="0">
+                  <a:pos x="csX10" y="csY10"/>
+                </a:cxn>
+                <a:cxn ang="0">
+                  <a:pos x="csX11" y="csY11"/>
+                </a:cxn>
+                <a:cxn ang="0">
+                  <a:pos x="csX12" y="csY12"/>
+                </a:cxn>
+                <a:cxn ang="0">
+                  <a:pos x="csX13" y="csY13"/>
+                </a:cxn>
+                <a:cxn ang="0">
+                  <a:pos x="csX14" y="csY14"/>
+                </a:cxn>
+                <a:cxn ang="0">
+                  <a:pos x="csX15" y="csY15"/>
+                </a:cxn>
+                <a:cxn ang="0">
+                  <a:pos x="csX16" y="csY16"/>
+                </a:cxn>
+                <a:cxn ang="0">
+                  <a:pos x="csX17" y="csY17"/>
+                </a:cxn>
+                <a:cxn ang="0">
+                  <a:pos x="csX18" y="csY18"/>
+                </a:cxn>
+                <a:cxn ang="0">
+                  <a:pos x="csX19" y="csY19"/>
+                </a:cxn>
+                <a:cxn ang="0">
+                  <a:pos x="csX20" y="csY20"/>
+                </a:cxn>
+                <a:cxn ang="0">
+                  <a:pos x="csX21" y="csY21"/>
+                </a:cxn>
+                <a:cxn ang="0">
+                  <a:pos x="csX22" y="csY22"/>
+                </a:cxn>
+                <a:cxn ang="0">
+                  <a:pos x="csX23" y="csY23"/>
+                </a:cxn>
+                <a:cxn ang="0">
+                  <a:pos x="csX24" y="csY24"/>
+                </a:cxn>
+                <a:cxn ang="0">
+                  <a:pos x="csX25" y="csY25"/>
+                </a:cxn>
+                <a:cxn ang="0">
+                  <a:pos x="csX26" y="csY26"/>
+                </a:cxn>
+                <a:cxn ang="0">
+                  <a:pos x="csX27" y="csY27"/>
+                </a:cxn>
+                <a:cxn ang="0">
+                  <a:pos x="csX28" y="csY28"/>
+                </a:cxn>
+                <a:cxn ang="0">
+                  <a:pos x="csX29" y="csY29"/>
+                </a:cxn>
+                <a:cxn ang="0">
+                  <a:pos x="csX30" y="csY30"/>
+                </a:cxn>
+                <a:cxn ang="0">
+                  <a:pos x="csX31" y="csY31"/>
+                </a:cxn>
+                <a:cxn ang="0">
+                  <a:pos x="csX32" y="csY32"/>
+                </a:cxn>
+                <a:cxn ang="0">
+                  <a:pos x="csX33" y="csY33"/>
+                </a:cxn>
+                <a:cxn ang="0">
+                  <a:pos x="csX34" y="csY34"/>
+                </a:cxn>
+                <a:cxn ang="0">
+                  <a:pos x="csX35" y="csY35"/>
+                </a:cxn>
+                <a:cxn ang="0">
+                  <a:pos x="csX36" y="csY36"/>
+                </a:cxn>
+                <a:cxn ang="0">
+                  <a:pos x="csX37" y="csY37"/>
+                </a:cxn>
+                <a:cxn ang="0">
+                  <a:pos x="csX38" y="csY38"/>
+                </a:cxn>
+              </a:cxnLst>
+              <a:rect l="l" t="t" r="r" b="b"/>
+              <a:pathLst>
+                <a:path w="1570382" h="477079">
+                  <a:moveTo>
+                    <a:pt x="0" y="0"/>
+                  </a:moveTo>
+                  <a:lnTo>
+                    <a:pt x="0" y="0"/>
+                  </a:lnTo>
+                  <a:cubicBezTo>
+                    <a:pt x="3313" y="33131"/>
+                    <a:pt x="3409" y="66743"/>
+                    <a:pt x="9939" y="99392"/>
+                  </a:cubicBezTo>
+                  <a:cubicBezTo>
+                    <a:pt x="13438" y="116887"/>
+                    <a:pt x="22571" y="132784"/>
+                    <a:pt x="29817" y="149087"/>
+                  </a:cubicBezTo>
+                  <a:cubicBezTo>
+                    <a:pt x="43523" y="179926"/>
+                    <a:pt x="50759" y="192320"/>
+                    <a:pt x="69574" y="218661"/>
+                  </a:cubicBezTo>
+                  <a:cubicBezTo>
+                    <a:pt x="77802" y="230181"/>
+                    <a:pt x="113152" y="280207"/>
+                    <a:pt x="129209" y="288235"/>
+                  </a:cubicBezTo>
+                  <a:cubicBezTo>
+                    <a:pt x="144319" y="295790"/>
+                    <a:pt x="162515" y="294077"/>
+                    <a:pt x="178904" y="298174"/>
+                  </a:cubicBezTo>
+                  <a:cubicBezTo>
+                    <a:pt x="189068" y="300715"/>
+                    <a:pt x="198414" y="306239"/>
+                    <a:pt x="208722" y="308113"/>
+                  </a:cubicBezTo>
+                  <a:cubicBezTo>
+                    <a:pt x="379345" y="339136"/>
+                    <a:pt x="222660" y="301659"/>
+                    <a:pt x="327991" y="327992"/>
+                  </a:cubicBezTo>
+                  <a:cubicBezTo>
+                    <a:pt x="337930" y="337931"/>
+                    <a:pt x="350012" y="346114"/>
+                    <a:pt x="357809" y="357809"/>
+                  </a:cubicBezTo>
+                  <a:cubicBezTo>
+                    <a:pt x="363620" y="366526"/>
+                    <a:pt x="359567" y="381081"/>
+                    <a:pt x="367748" y="387626"/>
+                  </a:cubicBezTo>
+                  <a:cubicBezTo>
+                    <a:pt x="378415" y="396159"/>
+                    <a:pt x="394370" y="393813"/>
+                    <a:pt x="407504" y="397566"/>
+                  </a:cubicBezTo>
+                  <a:cubicBezTo>
+                    <a:pt x="417578" y="400444"/>
+                    <a:pt x="427095" y="405232"/>
+                    <a:pt x="437322" y="407505"/>
+                  </a:cubicBezTo>
+                  <a:cubicBezTo>
+                    <a:pt x="456994" y="411877"/>
+                    <a:pt x="477405" y="412556"/>
+                    <a:pt x="496956" y="417444"/>
+                  </a:cubicBezTo>
+                  <a:cubicBezTo>
+                    <a:pt x="517284" y="422526"/>
+                    <a:pt x="556591" y="437322"/>
+                    <a:pt x="556591" y="437322"/>
+                  </a:cubicBezTo>
+                  <a:cubicBezTo>
+                    <a:pt x="566530" y="447261"/>
+                    <a:pt x="574713" y="459343"/>
+                    <a:pt x="586409" y="467140"/>
+                  </a:cubicBezTo>
+                  <a:cubicBezTo>
+                    <a:pt x="595126" y="472951"/>
+                    <a:pt x="605749" y="477079"/>
+                    <a:pt x="616226" y="477079"/>
+                  </a:cubicBezTo>
+                  <a:cubicBezTo>
+                    <a:pt x="672645" y="477079"/>
+                    <a:pt x="728869" y="470453"/>
+                    <a:pt x="785191" y="467140"/>
+                  </a:cubicBezTo>
+                  <a:cubicBezTo>
+                    <a:pt x="795130" y="463827"/>
+                    <a:pt x="804935" y="460078"/>
+                    <a:pt x="815009" y="457200"/>
+                  </a:cubicBezTo>
+                  <a:cubicBezTo>
+                    <a:pt x="857316" y="445112"/>
+                    <a:pt x="916134" y="434987"/>
+                    <a:pt x="954156" y="427383"/>
+                  </a:cubicBezTo>
+                  <a:cubicBezTo>
+                    <a:pt x="970721" y="424070"/>
+                    <a:pt x="987826" y="422786"/>
+                    <a:pt x="1003852" y="417444"/>
+                  </a:cubicBezTo>
+                  <a:lnTo>
+                    <a:pt x="1093304" y="387626"/>
+                  </a:lnTo>
+                  <a:lnTo>
+                    <a:pt x="1123122" y="377687"/>
+                  </a:lnTo>
+                  <a:cubicBezTo>
+                    <a:pt x="1133061" y="374374"/>
+                    <a:pt x="1142605" y="369470"/>
+                    <a:pt x="1152939" y="367748"/>
+                  </a:cubicBezTo>
+                  <a:lnTo>
+                    <a:pt x="1212574" y="357809"/>
+                  </a:lnTo>
+                  <a:cubicBezTo>
+                    <a:pt x="1222513" y="354496"/>
+                    <a:pt x="1234210" y="354415"/>
+                    <a:pt x="1242391" y="347870"/>
+                  </a:cubicBezTo>
+                  <a:cubicBezTo>
+                    <a:pt x="1251719" y="340408"/>
+                    <a:pt x="1254807" y="327381"/>
+                    <a:pt x="1262269" y="318053"/>
+                  </a:cubicBezTo>
+                  <a:cubicBezTo>
+                    <a:pt x="1268123" y="310735"/>
+                    <a:pt x="1276294" y="305492"/>
+                    <a:pt x="1282148" y="298174"/>
+                  </a:cubicBezTo>
+                  <a:cubicBezTo>
+                    <a:pt x="1289610" y="288846"/>
+                    <a:pt x="1293579" y="276804"/>
+                    <a:pt x="1302026" y="268357"/>
+                  </a:cubicBezTo>
+                  <a:cubicBezTo>
+                    <a:pt x="1310473" y="259910"/>
+                    <a:pt x="1322515" y="255941"/>
+                    <a:pt x="1331843" y="248479"/>
+                  </a:cubicBezTo>
+                  <a:cubicBezTo>
+                    <a:pt x="1339161" y="242625"/>
+                    <a:pt x="1343340" y="232791"/>
+                    <a:pt x="1351722" y="228600"/>
+                  </a:cubicBezTo>
+                  <a:cubicBezTo>
+                    <a:pt x="1363940" y="222491"/>
+                    <a:pt x="1378394" y="222586"/>
+                    <a:pt x="1391478" y="218661"/>
+                  </a:cubicBezTo>
+                  <a:cubicBezTo>
+                    <a:pt x="1411548" y="212640"/>
+                    <a:pt x="1431235" y="205409"/>
+                    <a:pt x="1451113" y="198783"/>
+                  </a:cubicBezTo>
+                  <a:cubicBezTo>
+                    <a:pt x="1461052" y="195470"/>
+                    <a:pt x="1470766" y="191385"/>
+                    <a:pt x="1480930" y="188844"/>
+                  </a:cubicBezTo>
+                  <a:lnTo>
+                    <a:pt x="1520687" y="178905"/>
+                  </a:lnTo>
+                  <a:cubicBezTo>
+                    <a:pt x="1527313" y="172279"/>
+                    <a:pt x="1536374" y="167408"/>
+                    <a:pt x="1540565" y="159026"/>
+                  </a:cubicBezTo>
+                  <a:cubicBezTo>
+                    <a:pt x="1549935" y="140285"/>
+                    <a:pt x="1553817" y="119270"/>
+                    <a:pt x="1560443" y="99392"/>
+                  </a:cubicBezTo>
+                  <a:cubicBezTo>
+                    <a:pt x="1563756" y="89453"/>
+                    <a:pt x="1570382" y="80051"/>
+                    <a:pt x="1570382" y="69574"/>
+                  </a:cubicBezTo>
+                  <a:lnTo>
+                    <a:pt x="1570382" y="19879"/>
+                  </a:lnTo>
+                </a:path>
+              </a:pathLst>
+            </a:custGeom>
+            <a:noFill/>
+          </p:spPr>
+          <p:style>
+            <a:lnRef idx="1">
+              <a:schemeClr val="accent1"/>
+            </a:lnRef>
+            <a:fillRef idx="3">
+              <a:schemeClr val="accent1"/>
+            </a:fillRef>
+            <a:effectRef idx="2">
+              <a:schemeClr val="accent1"/>
+            </a:effectRef>
+            <a:fontRef idx="minor">
+              <a:schemeClr val="lt1"/>
+            </a:fontRef>
+          </p:style>
+          <p:txBody>
+            <a:bodyPr rtlCol="0" anchor="ctr"/>
+            <a:lstStyle/>
+            <a:p>
+              <a:pPr algn="ctr"/>
+              <a:endParaRPr lang="en-US" dirty="0"/>
+            </a:p>
+          </p:txBody>
+        </p:sp>
+        <p:cxnSp>
+          <p:nvCxnSpPr>
+            <p:cNvPr id="9" name="Straight Connector 8">
+              <a:extLst>
+                <a:ext uri="{FF2B5EF4-FFF2-40B4-BE49-F238E27FC236}">
+                  <a16:creationId xmlns:a16="http://schemas.microsoft.com/office/drawing/2014/main" id="{CB750CDE-5E71-0270-4B5B-1F8F2D906C11}"/>
+                </a:ext>
+              </a:extLst>
+            </p:cNvPr>
+            <p:cNvCxnSpPr>
+              <a:cxnSpLocks/>
+            </p:cNvCxnSpPr>
+            <p:nvPr/>
+          </p:nvCxnSpPr>
+          <p:spPr>
+            <a:xfrm>
+              <a:off x="5138530" y="1455480"/>
+              <a:ext cx="1958009" cy="0"/>
+            </a:xfrm>
+            <a:prstGeom prst="line">
+              <a:avLst/>
+            </a:prstGeom>
+          </p:spPr>
+          <p:style>
+            <a:lnRef idx="2">
+              <a:schemeClr val="accent1"/>
+            </a:lnRef>
+            <a:fillRef idx="0">
+              <a:schemeClr val="accent1"/>
+            </a:fillRef>
+            <a:effectRef idx="1">
+              <a:schemeClr val="accent1"/>
+            </a:effectRef>
+            <a:fontRef idx="minor">
+              <a:schemeClr val="tx1"/>
+            </a:fontRef>
+          </p:style>
+        </p:cxnSp>
+        <p:sp>
+          <p:nvSpPr>
+            <p:cNvPr id="10" name="Freeform 9">
+              <a:extLst>
+                <a:ext uri="{FF2B5EF4-FFF2-40B4-BE49-F238E27FC236}">
+                  <a16:creationId xmlns:a16="http://schemas.microsoft.com/office/drawing/2014/main" id="{9A1A9E75-CE5B-76CD-9642-856875039DB9}"/>
+                </a:ext>
+              </a:extLst>
+            </p:cNvPr>
+            <p:cNvSpPr/>
+            <p:nvPr/>
+          </p:nvSpPr>
+          <p:spPr>
+            <a:xfrm>
+              <a:off x="3597964" y="1543844"/>
+              <a:ext cx="1520687" cy="233533"/>
+            </a:xfrm>
+            <a:custGeom>
+              <a:avLst/>
+              <a:gdLst>
+                <a:gd name="csX0" fmla="*/ 0 w 1560444"/>
+                <a:gd name="csY0" fmla="*/ 42846 h 360898"/>
+                <a:gd name="csX1" fmla="*/ 0 w 1560444"/>
+                <a:gd name="csY1" fmla="*/ 42846 h 360898"/>
+                <a:gd name="csX2" fmla="*/ 89453 w 1560444"/>
+                <a:gd name="csY2" fmla="*/ 132298 h 360898"/>
+                <a:gd name="csX3" fmla="*/ 139148 w 1560444"/>
+                <a:gd name="csY3" fmla="*/ 172055 h 360898"/>
+                <a:gd name="csX4" fmla="*/ 149087 w 1560444"/>
+                <a:gd name="csY4" fmla="*/ 201872 h 360898"/>
+                <a:gd name="csX5" fmla="*/ 178905 w 1560444"/>
+                <a:gd name="csY5" fmla="*/ 211811 h 360898"/>
+                <a:gd name="csX6" fmla="*/ 298174 w 1560444"/>
+                <a:gd name="csY6" fmla="*/ 201872 h 360898"/>
+                <a:gd name="csX7" fmla="*/ 308114 w 1560444"/>
+                <a:gd name="csY7" fmla="*/ 231689 h 360898"/>
+                <a:gd name="csX8" fmla="*/ 387627 w 1560444"/>
+                <a:gd name="csY8" fmla="*/ 271446 h 360898"/>
+                <a:gd name="csX9" fmla="*/ 417444 w 1560444"/>
+                <a:gd name="csY9" fmla="*/ 281385 h 360898"/>
+                <a:gd name="csX10" fmla="*/ 447261 w 1560444"/>
+                <a:gd name="csY10" fmla="*/ 291324 h 360898"/>
+                <a:gd name="csX11" fmla="*/ 487018 w 1560444"/>
+                <a:gd name="csY11" fmla="*/ 301263 h 360898"/>
+                <a:gd name="csX12" fmla="*/ 546653 w 1560444"/>
+                <a:gd name="csY12" fmla="*/ 321142 h 360898"/>
+                <a:gd name="csX13" fmla="*/ 566531 w 1560444"/>
+                <a:gd name="csY13" fmla="*/ 350959 h 360898"/>
+                <a:gd name="csX14" fmla="*/ 596348 w 1560444"/>
+                <a:gd name="csY14" fmla="*/ 360898 h 360898"/>
+                <a:gd name="csX15" fmla="*/ 745435 w 1560444"/>
+                <a:gd name="csY15" fmla="*/ 350959 h 360898"/>
+                <a:gd name="csX16" fmla="*/ 805070 w 1560444"/>
+                <a:gd name="csY16" fmla="*/ 321142 h 360898"/>
+                <a:gd name="csX17" fmla="*/ 834887 w 1560444"/>
+                <a:gd name="csY17" fmla="*/ 311202 h 360898"/>
+                <a:gd name="csX18" fmla="*/ 864705 w 1560444"/>
+                <a:gd name="csY18" fmla="*/ 291324 h 360898"/>
+                <a:gd name="csX19" fmla="*/ 924340 w 1560444"/>
+                <a:gd name="csY19" fmla="*/ 271446 h 360898"/>
+                <a:gd name="csX20" fmla="*/ 954157 w 1560444"/>
+                <a:gd name="csY20" fmla="*/ 251568 h 360898"/>
+                <a:gd name="csX21" fmla="*/ 1103244 w 1560444"/>
+                <a:gd name="csY21" fmla="*/ 231689 h 360898"/>
+                <a:gd name="csX22" fmla="*/ 1202635 w 1560444"/>
+                <a:gd name="csY22" fmla="*/ 211811 h 360898"/>
+                <a:gd name="csX23" fmla="*/ 1232453 w 1560444"/>
+                <a:gd name="csY23" fmla="*/ 201872 h 360898"/>
+                <a:gd name="csX24" fmla="*/ 1272209 w 1560444"/>
+                <a:gd name="csY24" fmla="*/ 142237 h 360898"/>
+                <a:gd name="csX25" fmla="*/ 1311966 w 1560444"/>
+                <a:gd name="csY25" fmla="*/ 112420 h 360898"/>
+                <a:gd name="csX26" fmla="*/ 1341783 w 1560444"/>
+                <a:gd name="csY26" fmla="*/ 92542 h 360898"/>
+                <a:gd name="csX27" fmla="*/ 1361661 w 1560444"/>
+                <a:gd name="csY27" fmla="*/ 72663 h 360898"/>
+                <a:gd name="csX28" fmla="*/ 1421296 w 1560444"/>
+                <a:gd name="csY28" fmla="*/ 52785 h 360898"/>
+                <a:gd name="csX29" fmla="*/ 1500809 w 1560444"/>
+                <a:gd name="csY29" fmla="*/ 32907 h 360898"/>
+                <a:gd name="csX30" fmla="*/ 1560444 w 1560444"/>
+                <a:gd name="csY30" fmla="*/ 13028 h 360898"/>
+                <a:gd name="csX31" fmla="*/ 1421296 w 1560444"/>
+                <a:gd name="csY31" fmla="*/ 3089 h 360898"/>
+                <a:gd name="csX32" fmla="*/ 0 w 1560444"/>
+                <a:gd name="csY32" fmla="*/ 42846 h 360898"/>
+                <a:gd name="csX0" fmla="*/ 0 w 1580322"/>
+                <a:gd name="csY0" fmla="*/ 0 h 367748"/>
+                <a:gd name="csX1" fmla="*/ 19878 w 1580322"/>
+                <a:gd name="csY1" fmla="*/ 49696 h 367748"/>
+                <a:gd name="csX2" fmla="*/ 109331 w 1580322"/>
+                <a:gd name="csY2" fmla="*/ 139148 h 367748"/>
+                <a:gd name="csX3" fmla="*/ 159026 w 1580322"/>
+                <a:gd name="csY3" fmla="*/ 178905 h 367748"/>
+                <a:gd name="csX4" fmla="*/ 168965 w 1580322"/>
+                <a:gd name="csY4" fmla="*/ 208722 h 367748"/>
+                <a:gd name="csX5" fmla="*/ 198783 w 1580322"/>
+                <a:gd name="csY5" fmla="*/ 218661 h 367748"/>
+                <a:gd name="csX6" fmla="*/ 318052 w 1580322"/>
+                <a:gd name="csY6" fmla="*/ 208722 h 367748"/>
+                <a:gd name="csX7" fmla="*/ 327992 w 1580322"/>
+                <a:gd name="csY7" fmla="*/ 238539 h 367748"/>
+                <a:gd name="csX8" fmla="*/ 407505 w 1580322"/>
+                <a:gd name="csY8" fmla="*/ 278296 h 367748"/>
+                <a:gd name="csX9" fmla="*/ 437322 w 1580322"/>
+                <a:gd name="csY9" fmla="*/ 288235 h 367748"/>
+                <a:gd name="csX10" fmla="*/ 467139 w 1580322"/>
+                <a:gd name="csY10" fmla="*/ 298174 h 367748"/>
+                <a:gd name="csX11" fmla="*/ 506896 w 1580322"/>
+                <a:gd name="csY11" fmla="*/ 308113 h 367748"/>
+                <a:gd name="csX12" fmla="*/ 566531 w 1580322"/>
+                <a:gd name="csY12" fmla="*/ 327992 h 367748"/>
+                <a:gd name="csX13" fmla="*/ 586409 w 1580322"/>
+                <a:gd name="csY13" fmla="*/ 357809 h 367748"/>
+                <a:gd name="csX14" fmla="*/ 616226 w 1580322"/>
+                <a:gd name="csY14" fmla="*/ 367748 h 367748"/>
+                <a:gd name="csX15" fmla="*/ 765313 w 1580322"/>
+                <a:gd name="csY15" fmla="*/ 357809 h 367748"/>
+                <a:gd name="csX16" fmla="*/ 824948 w 1580322"/>
+                <a:gd name="csY16" fmla="*/ 327992 h 367748"/>
+                <a:gd name="csX17" fmla="*/ 854765 w 1580322"/>
+                <a:gd name="csY17" fmla="*/ 318052 h 367748"/>
+                <a:gd name="csX18" fmla="*/ 884583 w 1580322"/>
+                <a:gd name="csY18" fmla="*/ 298174 h 367748"/>
+                <a:gd name="csX19" fmla="*/ 944218 w 1580322"/>
+                <a:gd name="csY19" fmla="*/ 278296 h 367748"/>
+                <a:gd name="csX20" fmla="*/ 974035 w 1580322"/>
+                <a:gd name="csY20" fmla="*/ 258418 h 367748"/>
+                <a:gd name="csX21" fmla="*/ 1123122 w 1580322"/>
+                <a:gd name="csY21" fmla="*/ 238539 h 367748"/>
+                <a:gd name="csX22" fmla="*/ 1222513 w 1580322"/>
+                <a:gd name="csY22" fmla="*/ 218661 h 367748"/>
+                <a:gd name="csX23" fmla="*/ 1252331 w 1580322"/>
+                <a:gd name="csY23" fmla="*/ 208722 h 367748"/>
+                <a:gd name="csX24" fmla="*/ 1292087 w 1580322"/>
+                <a:gd name="csY24" fmla="*/ 149087 h 367748"/>
+                <a:gd name="csX25" fmla="*/ 1331844 w 1580322"/>
+                <a:gd name="csY25" fmla="*/ 119270 h 367748"/>
+                <a:gd name="csX26" fmla="*/ 1361661 w 1580322"/>
+                <a:gd name="csY26" fmla="*/ 99392 h 367748"/>
+                <a:gd name="csX27" fmla="*/ 1381539 w 1580322"/>
+                <a:gd name="csY27" fmla="*/ 79513 h 367748"/>
+                <a:gd name="csX28" fmla="*/ 1441174 w 1580322"/>
+                <a:gd name="csY28" fmla="*/ 59635 h 367748"/>
+                <a:gd name="csX29" fmla="*/ 1520687 w 1580322"/>
+                <a:gd name="csY29" fmla="*/ 39757 h 367748"/>
+                <a:gd name="csX30" fmla="*/ 1580322 w 1580322"/>
+                <a:gd name="csY30" fmla="*/ 19878 h 367748"/>
+                <a:gd name="csX31" fmla="*/ 1441174 w 1580322"/>
+                <a:gd name="csY31" fmla="*/ 9939 h 367748"/>
+                <a:gd name="csX32" fmla="*/ 0 w 1580322"/>
+                <a:gd name="csY32" fmla="*/ 0 h 367748"/>
+                <a:gd name="csX0" fmla="*/ 0 w 1520687"/>
+                <a:gd name="csY0" fmla="*/ 0 h 367748"/>
+                <a:gd name="csX1" fmla="*/ 19878 w 1520687"/>
+                <a:gd name="csY1" fmla="*/ 49696 h 367748"/>
+                <a:gd name="csX2" fmla="*/ 109331 w 1520687"/>
+                <a:gd name="csY2" fmla="*/ 139148 h 367748"/>
+                <a:gd name="csX3" fmla="*/ 159026 w 1520687"/>
+                <a:gd name="csY3" fmla="*/ 178905 h 367748"/>
+                <a:gd name="csX4" fmla="*/ 168965 w 1520687"/>
+                <a:gd name="csY4" fmla="*/ 208722 h 367748"/>
+                <a:gd name="csX5" fmla="*/ 198783 w 1520687"/>
+                <a:gd name="csY5" fmla="*/ 218661 h 367748"/>
+                <a:gd name="csX6" fmla="*/ 318052 w 1520687"/>
+                <a:gd name="csY6" fmla="*/ 208722 h 367748"/>
+                <a:gd name="csX7" fmla="*/ 327992 w 1520687"/>
+                <a:gd name="csY7" fmla="*/ 238539 h 367748"/>
+                <a:gd name="csX8" fmla="*/ 407505 w 1520687"/>
+                <a:gd name="csY8" fmla="*/ 278296 h 367748"/>
+                <a:gd name="csX9" fmla="*/ 437322 w 1520687"/>
+                <a:gd name="csY9" fmla="*/ 288235 h 367748"/>
+                <a:gd name="csX10" fmla="*/ 467139 w 1520687"/>
+                <a:gd name="csY10" fmla="*/ 298174 h 367748"/>
+                <a:gd name="csX11" fmla="*/ 506896 w 1520687"/>
+                <a:gd name="csY11" fmla="*/ 308113 h 367748"/>
+                <a:gd name="csX12" fmla="*/ 566531 w 1520687"/>
+                <a:gd name="csY12" fmla="*/ 327992 h 367748"/>
+                <a:gd name="csX13" fmla="*/ 586409 w 1520687"/>
+                <a:gd name="csY13" fmla="*/ 357809 h 367748"/>
+                <a:gd name="csX14" fmla="*/ 616226 w 1520687"/>
+                <a:gd name="csY14" fmla="*/ 367748 h 367748"/>
+                <a:gd name="csX15" fmla="*/ 765313 w 1520687"/>
+                <a:gd name="csY15" fmla="*/ 357809 h 367748"/>
+                <a:gd name="csX16" fmla="*/ 824948 w 1520687"/>
+                <a:gd name="csY16" fmla="*/ 327992 h 367748"/>
+                <a:gd name="csX17" fmla="*/ 854765 w 1520687"/>
+                <a:gd name="csY17" fmla="*/ 318052 h 367748"/>
+                <a:gd name="csX18" fmla="*/ 884583 w 1520687"/>
+                <a:gd name="csY18" fmla="*/ 298174 h 367748"/>
+                <a:gd name="csX19" fmla="*/ 944218 w 1520687"/>
+                <a:gd name="csY19" fmla="*/ 278296 h 367748"/>
+                <a:gd name="csX20" fmla="*/ 974035 w 1520687"/>
+                <a:gd name="csY20" fmla="*/ 258418 h 367748"/>
+                <a:gd name="csX21" fmla="*/ 1123122 w 1520687"/>
+                <a:gd name="csY21" fmla="*/ 238539 h 367748"/>
+                <a:gd name="csX22" fmla="*/ 1222513 w 1520687"/>
+                <a:gd name="csY22" fmla="*/ 218661 h 367748"/>
+                <a:gd name="csX23" fmla="*/ 1252331 w 1520687"/>
+                <a:gd name="csY23" fmla="*/ 208722 h 367748"/>
+                <a:gd name="csX24" fmla="*/ 1292087 w 1520687"/>
+                <a:gd name="csY24" fmla="*/ 149087 h 367748"/>
+                <a:gd name="csX25" fmla="*/ 1331844 w 1520687"/>
+                <a:gd name="csY25" fmla="*/ 119270 h 367748"/>
+                <a:gd name="csX26" fmla="*/ 1361661 w 1520687"/>
+                <a:gd name="csY26" fmla="*/ 99392 h 367748"/>
+                <a:gd name="csX27" fmla="*/ 1381539 w 1520687"/>
+                <a:gd name="csY27" fmla="*/ 79513 h 367748"/>
+                <a:gd name="csX28" fmla="*/ 1441174 w 1520687"/>
+                <a:gd name="csY28" fmla="*/ 59635 h 367748"/>
+                <a:gd name="csX29" fmla="*/ 1520687 w 1520687"/>
+                <a:gd name="csY29" fmla="*/ 39757 h 367748"/>
+                <a:gd name="csX30" fmla="*/ 1441174 w 1520687"/>
+                <a:gd name="csY30" fmla="*/ 9939 h 367748"/>
+                <a:gd name="csX31" fmla="*/ 0 w 1520687"/>
+                <a:gd name="csY31" fmla="*/ 0 h 367748"/>
+              </a:gdLst>
+              <a:ahLst/>
+              <a:cxnLst>
+                <a:cxn ang="0">
+                  <a:pos x="csX0" y="csY0"/>
+                </a:cxn>
+                <a:cxn ang="0">
+                  <a:pos x="csX1" y="csY1"/>
+                </a:cxn>
+                <a:cxn ang="0">
+                  <a:pos x="csX2" y="csY2"/>
+                </a:cxn>
+                <a:cxn ang="0">
+                  <a:pos x="csX3" y="csY3"/>
+                </a:cxn>
+                <a:cxn ang="0">
+                  <a:pos x="csX4" y="csY4"/>
+                </a:cxn>
+                <a:cxn ang="0">
+                  <a:pos x="csX5" y="csY5"/>
+                </a:cxn>
+                <a:cxn ang="0">
+                  <a:pos x="csX6" y="csY6"/>
+                </a:cxn>
+                <a:cxn ang="0">
+                  <a:pos x="csX7" y="csY7"/>
+                </a:cxn>
+                <a:cxn ang="0">
+                  <a:pos x="csX8" y="csY8"/>
+                </a:cxn>
+                <a:cxn ang="0">
+                  <a:pos x="csX9" y="csY9"/>
+                </a:cxn>
+                <a:cxn ang="0">
+                  <a:pos x="csX10" y="csY10"/>
+                </a:cxn>
+                <a:cxn ang="0">
+                  <a:pos x="csX11" y="csY11"/>
+                </a:cxn>
+                <a:cxn ang="0">
+                  <a:pos x="csX12" y="csY12"/>
+                </a:cxn>
+                <a:cxn ang="0">
+                  <a:pos x="csX13" y="csY13"/>
+                </a:cxn>
+                <a:cxn ang="0">
+                  <a:pos x="csX14" y="csY14"/>
+                </a:cxn>
+                <a:cxn ang="0">
+                  <a:pos x="csX15" y="csY15"/>
+                </a:cxn>
+                <a:cxn ang="0">
+                  <a:pos x="csX16" y="csY16"/>
+                </a:cxn>
+                <a:cxn ang="0">
+                  <a:pos x="csX17" y="csY17"/>
+                </a:cxn>
+                <a:cxn ang="0">
+                  <a:pos x="csX18" y="csY18"/>
+                </a:cxn>
+                <a:cxn ang="0">
+                  <a:pos x="csX19" y="csY19"/>
+                </a:cxn>
+                <a:cxn ang="0">
+                  <a:pos x="csX20" y="csY20"/>
+                </a:cxn>
+                <a:cxn ang="0">
+                  <a:pos x="csX21" y="csY21"/>
+                </a:cxn>
+                <a:cxn ang="0">
+                  <a:pos x="csX22" y="csY22"/>
+                </a:cxn>
+                <a:cxn ang="0">
+                  <a:pos x="csX23" y="csY23"/>
+                </a:cxn>
+                <a:cxn ang="0">
+                  <a:pos x="csX24" y="csY24"/>
+                </a:cxn>
+                <a:cxn ang="0">
+                  <a:pos x="csX25" y="csY25"/>
+                </a:cxn>
+                <a:cxn ang="0">
+                  <a:pos x="csX26" y="csY26"/>
+                </a:cxn>
+                <a:cxn ang="0">
+                  <a:pos x="csX27" y="csY27"/>
+                </a:cxn>
+                <a:cxn ang="0">
+                  <a:pos x="csX28" y="csY28"/>
+                </a:cxn>
+                <a:cxn ang="0">
+                  <a:pos x="csX29" y="csY29"/>
+                </a:cxn>
+                <a:cxn ang="0">
+                  <a:pos x="csX30" y="csY30"/>
+                </a:cxn>
+                <a:cxn ang="0">
+                  <a:pos x="csX31" y="csY31"/>
+                </a:cxn>
+              </a:cxnLst>
+              <a:rect l="l" t="t" r="r" b="b"/>
+              <a:pathLst>
+                <a:path w="1520687" h="367748">
+                  <a:moveTo>
+                    <a:pt x="0" y="0"/>
+                  </a:moveTo>
+                  <a:lnTo>
+                    <a:pt x="19878" y="49696"/>
+                  </a:lnTo>
+                  <a:cubicBezTo>
+                    <a:pt x="49696" y="79513"/>
+                    <a:pt x="74245" y="115757"/>
+                    <a:pt x="109331" y="139148"/>
+                  </a:cubicBezTo>
+                  <a:cubicBezTo>
+                    <a:pt x="146945" y="164224"/>
+                    <a:pt x="130702" y="150579"/>
+                    <a:pt x="159026" y="178905"/>
+                  </a:cubicBezTo>
+                  <a:cubicBezTo>
+                    <a:pt x="162339" y="188844"/>
+                    <a:pt x="161557" y="201314"/>
+                    <a:pt x="168965" y="208722"/>
+                  </a:cubicBezTo>
+                  <a:cubicBezTo>
+                    <a:pt x="176373" y="216130"/>
+                    <a:pt x="188306" y="218661"/>
+                    <a:pt x="198783" y="218661"/>
+                  </a:cubicBezTo>
+                  <a:cubicBezTo>
+                    <a:pt x="238677" y="218661"/>
+                    <a:pt x="278296" y="212035"/>
+                    <a:pt x="318052" y="208722"/>
+                  </a:cubicBezTo>
+                  <a:cubicBezTo>
+                    <a:pt x="321365" y="218661"/>
+                    <a:pt x="322602" y="229555"/>
+                    <a:pt x="327992" y="238539"/>
+                  </a:cubicBezTo>
+                  <a:cubicBezTo>
+                    <a:pt x="345341" y="267453"/>
+                    <a:pt x="377765" y="268383"/>
+                    <a:pt x="407505" y="278296"/>
+                  </a:cubicBezTo>
+                  <a:lnTo>
+                    <a:pt x="437322" y="288235"/>
+                  </a:lnTo>
+                  <a:cubicBezTo>
+                    <a:pt x="447261" y="291548"/>
+                    <a:pt x="456975" y="295633"/>
+                    <a:pt x="467139" y="298174"/>
+                  </a:cubicBezTo>
+                  <a:cubicBezTo>
+                    <a:pt x="480391" y="301487"/>
+                    <a:pt x="493812" y="304188"/>
+                    <a:pt x="506896" y="308113"/>
+                  </a:cubicBezTo>
+                  <a:cubicBezTo>
+                    <a:pt x="526966" y="314134"/>
+                    <a:pt x="566531" y="327992"/>
+                    <a:pt x="566531" y="327992"/>
+                  </a:cubicBezTo>
+                  <a:cubicBezTo>
+                    <a:pt x="573157" y="337931"/>
+                    <a:pt x="577081" y="350347"/>
+                    <a:pt x="586409" y="357809"/>
+                  </a:cubicBezTo>
+                  <a:cubicBezTo>
+                    <a:pt x="594590" y="364354"/>
+                    <a:pt x="605749" y="367748"/>
+                    <a:pt x="616226" y="367748"/>
+                  </a:cubicBezTo>
+                  <a:cubicBezTo>
+                    <a:pt x="666032" y="367748"/>
+                    <a:pt x="715617" y="361122"/>
+                    <a:pt x="765313" y="357809"/>
+                  </a:cubicBezTo>
+                  <a:cubicBezTo>
+                    <a:pt x="840252" y="332830"/>
+                    <a:pt x="747890" y="366522"/>
+                    <a:pt x="824948" y="327992"/>
+                  </a:cubicBezTo>
+                  <a:cubicBezTo>
+                    <a:pt x="834319" y="323307"/>
+                    <a:pt x="845394" y="322737"/>
+                    <a:pt x="854765" y="318052"/>
+                  </a:cubicBezTo>
+                  <a:cubicBezTo>
+                    <a:pt x="865449" y="312710"/>
+                    <a:pt x="873667" y="303025"/>
+                    <a:pt x="884583" y="298174"/>
+                  </a:cubicBezTo>
+                  <a:cubicBezTo>
+                    <a:pt x="903731" y="289664"/>
+                    <a:pt x="944218" y="278296"/>
+                    <a:pt x="944218" y="278296"/>
+                  </a:cubicBezTo>
+                  <a:cubicBezTo>
+                    <a:pt x="954157" y="271670"/>
+                    <a:pt x="963351" y="263760"/>
+                    <a:pt x="974035" y="258418"/>
+                  </a:cubicBezTo>
+                  <a:cubicBezTo>
+                    <a:pt x="1015137" y="237866"/>
+                    <a:pt x="1094555" y="241713"/>
+                    <a:pt x="1123122" y="238539"/>
+                  </a:cubicBezTo>
+                  <a:cubicBezTo>
+                    <a:pt x="1155074" y="234989"/>
+                    <a:pt x="1191103" y="227635"/>
+                    <a:pt x="1222513" y="218661"/>
+                  </a:cubicBezTo>
+                  <a:cubicBezTo>
+                    <a:pt x="1232587" y="215783"/>
+                    <a:pt x="1242392" y="212035"/>
+                    <a:pt x="1252331" y="208722"/>
+                  </a:cubicBezTo>
+                  <a:cubicBezTo>
+                    <a:pt x="1265583" y="188844"/>
+                    <a:pt x="1272974" y="163421"/>
+                    <a:pt x="1292087" y="149087"/>
+                  </a:cubicBezTo>
+                  <a:cubicBezTo>
+                    <a:pt x="1305339" y="139148"/>
+                    <a:pt x="1318364" y="128898"/>
+                    <a:pt x="1331844" y="119270"/>
+                  </a:cubicBezTo>
+                  <a:cubicBezTo>
+                    <a:pt x="1341564" y="112327"/>
+                    <a:pt x="1352333" y="106854"/>
+                    <a:pt x="1361661" y="99392"/>
+                  </a:cubicBezTo>
+                  <a:cubicBezTo>
+                    <a:pt x="1368978" y="93538"/>
+                    <a:pt x="1373158" y="83704"/>
+                    <a:pt x="1381539" y="79513"/>
+                  </a:cubicBezTo>
+                  <a:cubicBezTo>
+                    <a:pt x="1400280" y="70142"/>
+                    <a:pt x="1420846" y="64717"/>
+                    <a:pt x="1441174" y="59635"/>
+                  </a:cubicBezTo>
+                  <a:cubicBezTo>
+                    <a:pt x="1467678" y="53009"/>
+                    <a:pt x="1494769" y="48397"/>
+                    <a:pt x="1520687" y="39757"/>
+                  </a:cubicBezTo>
+                  <a:lnTo>
+                    <a:pt x="1441174" y="9939"/>
+                  </a:lnTo>
+                  <a:lnTo>
+                    <a:pt x="0" y="0"/>
+                  </a:lnTo>
+                  <a:close/>
+                </a:path>
+              </a:pathLst>
+            </a:custGeom>
+          </p:spPr>
+          <p:style>
+            <a:lnRef idx="1">
+              <a:schemeClr val="accent1"/>
+            </a:lnRef>
+            <a:fillRef idx="3">
+              <a:schemeClr val="accent1"/>
+            </a:fillRef>
+            <a:effectRef idx="2">
+              <a:schemeClr val="accent1"/>
+            </a:effectRef>
+            <a:fontRef idx="minor">
+              <a:schemeClr val="lt1"/>
+            </a:fontRef>
+          </p:style>
+          <p:txBody>
+            <a:bodyPr rtlCol="0" anchor="ctr"/>
+            <a:lstStyle/>
+            <a:p>
+              <a:pPr algn="ctr"/>
+              <a:endParaRPr lang="en-US" dirty="0"/>
+            </a:p>
+            <a:p>
+              <a:pPr algn="ctr"/>
+              <a:endParaRPr lang="en-US" dirty="0"/>
+            </a:p>
+          </p:txBody>
+        </p:sp>
+        <p:cxnSp>
+          <p:nvCxnSpPr>
+            <p:cNvPr id="12" name="Straight Connector 11">
+              <a:extLst>
+                <a:ext uri="{FF2B5EF4-FFF2-40B4-BE49-F238E27FC236}">
+                  <a16:creationId xmlns:a16="http://schemas.microsoft.com/office/drawing/2014/main" id="{7863613B-1E9C-65F5-7645-54D35EE0E2AC}"/>
+                </a:ext>
+              </a:extLst>
+            </p:cNvPr>
+            <p:cNvCxnSpPr>
+              <a:cxnSpLocks/>
+            </p:cNvCxnSpPr>
+            <p:nvPr/>
+          </p:nvCxnSpPr>
+          <p:spPr>
+            <a:xfrm>
+              <a:off x="1610139" y="3235380"/>
+              <a:ext cx="5486400" cy="0"/>
+            </a:xfrm>
+            <a:prstGeom prst="line">
+              <a:avLst/>
+            </a:prstGeom>
+          </p:spPr>
+          <p:style>
+            <a:lnRef idx="2">
+              <a:schemeClr val="accent1"/>
+            </a:lnRef>
+            <a:fillRef idx="0">
+              <a:schemeClr val="accent1"/>
+            </a:fillRef>
+            <a:effectRef idx="1">
+              <a:schemeClr val="accent1"/>
+            </a:effectRef>
+            <a:fontRef idx="minor">
+              <a:schemeClr val="tx1"/>
+            </a:fontRef>
+          </p:style>
+        </p:cxnSp>
+        <p:sp>
+          <p:nvSpPr>
+            <p:cNvPr id="14" name="Arc 13">
+              <a:extLst>
+                <a:ext uri="{FF2B5EF4-FFF2-40B4-BE49-F238E27FC236}">
+                  <a16:creationId xmlns:a16="http://schemas.microsoft.com/office/drawing/2014/main" id="{FD583CD4-D4A6-CB65-0807-C534A34D551A}"/>
+                </a:ext>
+              </a:extLst>
+            </p:cNvPr>
+            <p:cNvSpPr/>
+            <p:nvPr/>
+          </p:nvSpPr>
+          <p:spPr>
+            <a:xfrm>
+              <a:off x="3011558" y="767513"/>
+              <a:ext cx="2464906" cy="1237080"/>
+            </a:xfrm>
+            <a:prstGeom prst="arc">
+              <a:avLst>
+                <a:gd name="adj1" fmla="val 863616"/>
+                <a:gd name="adj2" fmla="val 9865649"/>
+              </a:avLst>
+            </a:prstGeom>
+            <a:ln w="9525">
+              <a:headEnd type="triangle"/>
+              <a:tailEnd type="triangle"/>
+            </a:ln>
+          </p:spPr>
+          <p:style>
+            <a:lnRef idx="2">
+              <a:schemeClr val="accent1"/>
+            </a:lnRef>
+            <a:fillRef idx="0">
+              <a:schemeClr val="accent1"/>
+            </a:fillRef>
+            <a:effectRef idx="1">
+              <a:schemeClr val="accent1"/>
+            </a:effectRef>
+            <a:fontRef idx="minor">
+              <a:schemeClr val="tx1"/>
+            </a:fontRef>
+          </p:style>
+          <p:txBody>
+            <a:bodyPr rtlCol="0" anchor="ctr"/>
+            <a:lstStyle/>
+            <a:p>
+              <a:pPr algn="ctr"/>
+              <a:endParaRPr lang="en-US" dirty="0"/>
+            </a:p>
+          </p:txBody>
+        </p:sp>
+        <p:sp>
+          <p:nvSpPr>
+            <p:cNvPr id="15" name="TextBox 14">
+              <a:extLst>
+                <a:ext uri="{FF2B5EF4-FFF2-40B4-BE49-F238E27FC236}">
+                  <a16:creationId xmlns:a16="http://schemas.microsoft.com/office/drawing/2014/main" id="{F1AF8947-BB53-844E-BDF3-47B9C87FF4EF}"/>
+                </a:ext>
+              </a:extLst>
+            </p:cNvPr>
+            <p:cNvSpPr txBox="1"/>
+            <p:nvPr/>
+          </p:nvSpPr>
+          <p:spPr>
+            <a:xfrm>
+              <a:off x="4104864" y="1890989"/>
+              <a:ext cx="354584" cy="234539"/>
+            </a:xfrm>
+            <a:prstGeom prst="rect">
+              <a:avLst/>
+            </a:prstGeom>
+            <a:solidFill>
+              <a:schemeClr val="bg1"/>
+            </a:solidFill>
+          </p:spPr>
+          <p:txBody>
+            <a:bodyPr wrap="none" rtlCol="0">
+              <a:spAutoFit/>
+            </a:bodyPr>
+            <a:lstStyle/>
+            <a:p>
+              <a:r>
+                <a:rPr lang="en-US" dirty="0"/>
+                <a:t>𝛀</a:t>
+              </a:r>
+            </a:p>
+          </p:txBody>
+        </p:sp>
+        <p:sp>
+          <p:nvSpPr>
+            <p:cNvPr id="16" name="Freeform 15">
+              <a:extLst>
+                <a:ext uri="{FF2B5EF4-FFF2-40B4-BE49-F238E27FC236}">
+                  <a16:creationId xmlns:a16="http://schemas.microsoft.com/office/drawing/2014/main" id="{C736B0E1-A928-3879-4835-023FCB6BF49A}"/>
+                </a:ext>
+              </a:extLst>
+            </p:cNvPr>
+            <p:cNvSpPr/>
+            <p:nvPr/>
+          </p:nvSpPr>
+          <p:spPr>
+            <a:xfrm>
+              <a:off x="5128591" y="1556466"/>
+              <a:ext cx="1997766" cy="82052"/>
+            </a:xfrm>
+            <a:custGeom>
+              <a:avLst/>
+              <a:gdLst>
+                <a:gd name="csX0" fmla="*/ 0 w 1997766"/>
+                <a:gd name="csY0" fmla="*/ 0 h 437322"/>
+                <a:gd name="csX1" fmla="*/ 854766 w 1997766"/>
+                <a:gd name="csY1" fmla="*/ 437322 h 437322"/>
+                <a:gd name="csX2" fmla="*/ 1997766 w 1997766"/>
+                <a:gd name="csY2" fmla="*/ 268357 h 437322"/>
+                <a:gd name="csX0" fmla="*/ 0 w 1997766"/>
+                <a:gd name="csY0" fmla="*/ 0 h 285851"/>
+                <a:gd name="csX1" fmla="*/ 775253 w 1997766"/>
+                <a:gd name="csY1" fmla="*/ 278296 h 285851"/>
+                <a:gd name="csX2" fmla="*/ 1997766 w 1997766"/>
+                <a:gd name="csY2" fmla="*/ 268357 h 285851"/>
+                <a:gd name="csX0" fmla="*/ 0 w 1997766"/>
+                <a:gd name="csY0" fmla="*/ 0 h 268357"/>
+                <a:gd name="csX1" fmla="*/ 1997766 w 1997766"/>
+                <a:gd name="csY1" fmla="*/ 268357 h 268357"/>
+                <a:gd name="csX0" fmla="*/ 0 w 1997766"/>
+                <a:gd name="csY0" fmla="*/ 0 h 268357"/>
+                <a:gd name="csX1" fmla="*/ 1997766 w 1997766"/>
+                <a:gd name="csY1" fmla="*/ 268357 h 268357"/>
+                <a:gd name="csX0" fmla="*/ 0 w 1997766"/>
+                <a:gd name="csY0" fmla="*/ 0 h 129209"/>
+                <a:gd name="csX1" fmla="*/ 1997766 w 1997766"/>
+                <a:gd name="csY1" fmla="*/ 129209 h 129209"/>
+                <a:gd name="csX0" fmla="*/ 0 w 1997766"/>
+                <a:gd name="csY0" fmla="*/ 0 h 129209"/>
+                <a:gd name="csX1" fmla="*/ 1997766 w 1997766"/>
+                <a:gd name="csY1" fmla="*/ 129209 h 129209"/>
+              </a:gdLst>
+              <a:ahLst/>
+              <a:cxnLst>
+                <a:cxn ang="0">
+                  <a:pos x="csX0" y="csY0"/>
+                </a:cxn>
+                <a:cxn ang="0">
+                  <a:pos x="csX1" y="csY1"/>
+                </a:cxn>
+              </a:cxnLst>
+              <a:rect l="l" t="t" r="r" b="b"/>
+              <a:pathLst>
+                <a:path w="1997766" h="129209">
+                  <a:moveTo>
+                    <a:pt x="0" y="0"/>
+                  </a:moveTo>
+                  <a:cubicBezTo>
+                    <a:pt x="616227" y="89452"/>
+                    <a:pt x="805070" y="119270"/>
+                    <a:pt x="1997766" y="129209"/>
+                  </a:cubicBezTo>
+                </a:path>
+              </a:pathLst>
+            </a:custGeom>
+            <a:noFill/>
+          </p:spPr>
+          <p:style>
+            <a:lnRef idx="1">
+              <a:schemeClr val="accent1"/>
+            </a:lnRef>
+            <a:fillRef idx="3">
+              <a:schemeClr val="accent1"/>
+            </a:fillRef>
+            <a:effectRef idx="2">
+              <a:schemeClr val="accent1"/>
+            </a:effectRef>
+            <a:fontRef idx="minor">
+              <a:schemeClr val="lt1"/>
+            </a:fontRef>
+          </p:style>
+          <p:txBody>
+            <a:bodyPr rtlCol="0" anchor="ctr"/>
+            <a:lstStyle/>
+            <a:p>
+              <a:pPr algn="ctr"/>
+              <a:endParaRPr lang="en-US" dirty="0"/>
+            </a:p>
+          </p:txBody>
+        </p:sp>
+        <p:sp>
+          <p:nvSpPr>
+            <p:cNvPr id="17" name="Freeform 16">
+              <a:extLst>
+                <a:ext uri="{FF2B5EF4-FFF2-40B4-BE49-F238E27FC236}">
+                  <a16:creationId xmlns:a16="http://schemas.microsoft.com/office/drawing/2014/main" id="{917EDAE2-A33E-227E-6FC2-E038E58BABFE}"/>
+                </a:ext>
+              </a:extLst>
+            </p:cNvPr>
+            <p:cNvSpPr/>
+            <p:nvPr/>
+          </p:nvSpPr>
+          <p:spPr>
+            <a:xfrm flipH="1">
+              <a:off x="1585290" y="1531218"/>
+              <a:ext cx="1997766" cy="82052"/>
+            </a:xfrm>
+            <a:custGeom>
+              <a:avLst/>
+              <a:gdLst>
+                <a:gd name="csX0" fmla="*/ 0 w 1997766"/>
+                <a:gd name="csY0" fmla="*/ 0 h 437322"/>
+                <a:gd name="csX1" fmla="*/ 854766 w 1997766"/>
+                <a:gd name="csY1" fmla="*/ 437322 h 437322"/>
+                <a:gd name="csX2" fmla="*/ 1997766 w 1997766"/>
+                <a:gd name="csY2" fmla="*/ 268357 h 437322"/>
+                <a:gd name="csX0" fmla="*/ 0 w 1997766"/>
+                <a:gd name="csY0" fmla="*/ 0 h 285851"/>
+                <a:gd name="csX1" fmla="*/ 775253 w 1997766"/>
+                <a:gd name="csY1" fmla="*/ 278296 h 285851"/>
+                <a:gd name="csX2" fmla="*/ 1997766 w 1997766"/>
+                <a:gd name="csY2" fmla="*/ 268357 h 285851"/>
+                <a:gd name="csX0" fmla="*/ 0 w 1997766"/>
+                <a:gd name="csY0" fmla="*/ 0 h 268357"/>
+                <a:gd name="csX1" fmla="*/ 1997766 w 1997766"/>
+                <a:gd name="csY1" fmla="*/ 268357 h 268357"/>
+                <a:gd name="csX0" fmla="*/ 0 w 1997766"/>
+                <a:gd name="csY0" fmla="*/ 0 h 268357"/>
+                <a:gd name="csX1" fmla="*/ 1997766 w 1997766"/>
+                <a:gd name="csY1" fmla="*/ 268357 h 268357"/>
+                <a:gd name="csX0" fmla="*/ 0 w 1997766"/>
+                <a:gd name="csY0" fmla="*/ 0 h 129209"/>
+                <a:gd name="csX1" fmla="*/ 1997766 w 1997766"/>
+                <a:gd name="csY1" fmla="*/ 129209 h 129209"/>
+                <a:gd name="csX0" fmla="*/ 0 w 1997766"/>
+                <a:gd name="csY0" fmla="*/ 0 h 129209"/>
+                <a:gd name="csX1" fmla="*/ 1997766 w 1997766"/>
+                <a:gd name="csY1" fmla="*/ 129209 h 129209"/>
+              </a:gdLst>
+              <a:ahLst/>
+              <a:cxnLst>
+                <a:cxn ang="0">
+                  <a:pos x="csX0" y="csY0"/>
+                </a:cxn>
+                <a:cxn ang="0">
+                  <a:pos x="csX1" y="csY1"/>
+                </a:cxn>
+              </a:cxnLst>
+              <a:rect l="l" t="t" r="r" b="b"/>
+              <a:pathLst>
+                <a:path w="1997766" h="129209">
+                  <a:moveTo>
+                    <a:pt x="0" y="0"/>
+                  </a:moveTo>
+                  <a:cubicBezTo>
+                    <a:pt x="616227" y="89452"/>
+                    <a:pt x="805070" y="119270"/>
+                    <a:pt x="1997766" y="129209"/>
+                  </a:cubicBezTo>
+                </a:path>
+              </a:pathLst>
+            </a:custGeom>
+            <a:noFill/>
+          </p:spPr>
+          <p:style>
+            <a:lnRef idx="1">
+              <a:schemeClr val="accent1"/>
+            </a:lnRef>
+            <a:fillRef idx="3">
+              <a:schemeClr val="accent1"/>
+            </a:fillRef>
+            <a:effectRef idx="2">
+              <a:schemeClr val="accent1"/>
+            </a:effectRef>
+            <a:fontRef idx="minor">
+              <a:schemeClr val="lt1"/>
+            </a:fontRef>
+          </p:style>
+          <p:txBody>
+            <a:bodyPr rtlCol="0" anchor="ctr"/>
+            <a:lstStyle/>
+            <a:p>
+              <a:pPr algn="ctr"/>
+              <a:endParaRPr lang="en-US" dirty="0"/>
+            </a:p>
+          </p:txBody>
+        </p:sp>
+        <p:cxnSp>
+          <p:nvCxnSpPr>
+            <p:cNvPr id="19" name="Straight Arrow Connector 18">
+              <a:extLst>
+                <a:ext uri="{FF2B5EF4-FFF2-40B4-BE49-F238E27FC236}">
+                  <a16:creationId xmlns:a16="http://schemas.microsoft.com/office/drawing/2014/main" id="{B25FF4C2-3153-F2E1-9721-1439A4A4A11A}"/>
+                </a:ext>
+              </a:extLst>
+            </p:cNvPr>
+            <p:cNvCxnSpPr>
+              <a:cxnSpLocks/>
+            </p:cNvCxnSpPr>
+            <p:nvPr/>
+          </p:nvCxnSpPr>
+          <p:spPr>
+            <a:xfrm>
+              <a:off x="6480313" y="1638519"/>
+              <a:ext cx="0" cy="1596862"/>
+            </a:xfrm>
+            <a:prstGeom prst="straightConnector1">
+              <a:avLst/>
+            </a:prstGeom>
+            <a:ln w="12700">
+              <a:headEnd type="triangle"/>
+              <a:tailEnd type="triangle"/>
+            </a:ln>
+          </p:spPr>
+          <p:style>
+            <a:lnRef idx="2">
+              <a:schemeClr val="accent1"/>
+            </a:lnRef>
+            <a:fillRef idx="0">
+              <a:schemeClr val="accent1"/>
+            </a:fillRef>
+            <a:effectRef idx="1">
+              <a:schemeClr val="accent1"/>
+            </a:effectRef>
+            <a:fontRef idx="minor">
+              <a:schemeClr val="tx1"/>
+            </a:fontRef>
+          </p:style>
+        </p:cxnSp>
+        <p:sp>
+          <p:nvSpPr>
+            <p:cNvPr id="21" name="TextBox 20">
+              <a:extLst>
+                <a:ext uri="{FF2B5EF4-FFF2-40B4-BE49-F238E27FC236}">
+                  <a16:creationId xmlns:a16="http://schemas.microsoft.com/office/drawing/2014/main" id="{1B4BF655-6F9F-DE62-11FA-259A05D8C7CE}"/>
+                </a:ext>
+              </a:extLst>
+            </p:cNvPr>
+            <p:cNvSpPr txBox="1"/>
+            <p:nvPr/>
+          </p:nvSpPr>
+          <p:spPr>
+            <a:xfrm>
+              <a:off x="6341166" y="2244443"/>
+              <a:ext cx="327334" cy="234539"/>
+            </a:xfrm>
+            <a:prstGeom prst="rect">
+              <a:avLst/>
+            </a:prstGeom>
+            <a:solidFill>
+              <a:schemeClr val="bg1"/>
+            </a:solidFill>
+          </p:spPr>
+          <p:txBody>
+            <a:bodyPr wrap="none" rtlCol="0">
+              <a:spAutoFit/>
+            </a:bodyPr>
+            <a:lstStyle/>
+            <a:p>
+              <a:r>
+                <a:rPr lang="en-US" i="1" dirty="0"/>
+                <a:t>D</a:t>
+              </a:r>
+            </a:p>
+          </p:txBody>
+        </p:sp>
+        <p:grpSp>
+          <p:nvGrpSpPr>
+            <p:cNvPr id="6" name="Group 5">
+              <a:extLst>
+                <a:ext uri="{FF2B5EF4-FFF2-40B4-BE49-F238E27FC236}">
+                  <a16:creationId xmlns:a16="http://schemas.microsoft.com/office/drawing/2014/main" id="{6C1DEB4B-0E43-D6D7-6050-4D61766AFBFF}"/>
+                </a:ext>
+              </a:extLst>
+            </p:cNvPr>
+            <p:cNvGrpSpPr/>
+            <p:nvPr/>
+          </p:nvGrpSpPr>
+          <p:grpSpPr>
+            <a:xfrm>
+              <a:off x="4484618" y="821655"/>
+              <a:ext cx="381836" cy="621200"/>
+              <a:chOff x="4484618" y="1089124"/>
+              <a:chExt cx="381836" cy="978212"/>
+            </a:xfrm>
+          </p:grpSpPr>
+          <p:cxnSp>
+            <p:nvCxnSpPr>
+              <p:cNvPr id="23" name="Straight Arrow Connector 22">
+                <a:extLst>
+                  <a:ext uri="{FF2B5EF4-FFF2-40B4-BE49-F238E27FC236}">
+                    <a16:creationId xmlns:a16="http://schemas.microsoft.com/office/drawing/2014/main" id="{D96CABA6-A33F-4BEF-25F2-2DAB3CA8F4E8}"/>
+                  </a:ext>
+                </a:extLst>
+              </p:cNvPr>
+              <p:cNvCxnSpPr/>
+              <p:nvPr/>
+            </p:nvCxnSpPr>
+            <p:spPr>
+              <a:xfrm>
+                <a:off x="4648285" y="1421293"/>
+                <a:ext cx="0" cy="646043"/>
+              </a:xfrm>
+              <a:prstGeom prst="straightConnector1">
+                <a:avLst/>
+              </a:prstGeom>
+              <a:ln>
+                <a:tailEnd type="triangle"/>
+              </a:ln>
+            </p:spPr>
+            <p:style>
+              <a:lnRef idx="2">
+                <a:schemeClr val="accent1"/>
+              </a:lnRef>
+              <a:fillRef idx="0">
+                <a:schemeClr val="accent1"/>
+              </a:fillRef>
+              <a:effectRef idx="1">
+                <a:schemeClr val="accent1"/>
+              </a:effectRef>
+              <a:fontRef idx="minor">
+                <a:schemeClr val="tx1"/>
+              </a:fontRef>
+            </p:style>
+          </p:cxnSp>
+          <p:sp>
+            <p:nvSpPr>
+              <p:cNvPr id="24" name="TextBox 23">
+                <a:extLst>
+                  <a:ext uri="{FF2B5EF4-FFF2-40B4-BE49-F238E27FC236}">
+                    <a16:creationId xmlns:a16="http://schemas.microsoft.com/office/drawing/2014/main" id="{F2050747-C7E2-4194-A5D4-EFD5FCF9B001}"/>
+                  </a:ext>
+                </a:extLst>
+              </p:cNvPr>
+              <p:cNvSpPr txBox="1"/>
+              <p:nvPr/>
+            </p:nvSpPr>
+            <p:spPr>
+              <a:xfrm>
+                <a:off x="4484618" y="1089124"/>
+                <a:ext cx="381836" cy="369332"/>
+              </a:xfrm>
+              <a:prstGeom prst="rect">
+                <a:avLst/>
+              </a:prstGeom>
+              <a:solidFill>
+                <a:schemeClr val="bg1"/>
+              </a:solidFill>
+            </p:spPr>
+            <p:txBody>
+              <a:bodyPr wrap="none" rtlCol="0">
+                <a:spAutoFit/>
+              </a:bodyPr>
+              <a:lstStyle/>
+              <a:p>
+                <a:r>
+                  <a:rPr lang="en-US" i="1" dirty="0"/>
+                  <a:t>q</a:t>
+                </a:r>
+                <a:r>
+                  <a:rPr lang="en-US" i="1" baseline="-25000" dirty="0"/>
+                  <a:t>0</a:t>
+                </a:r>
+              </a:p>
+            </p:txBody>
+          </p:sp>
+        </p:grpSp>
+        <p:cxnSp>
+          <p:nvCxnSpPr>
+            <p:cNvPr id="4" name="Straight Connector 3">
+              <a:extLst>
+                <a:ext uri="{FF2B5EF4-FFF2-40B4-BE49-F238E27FC236}">
+                  <a16:creationId xmlns:a16="http://schemas.microsoft.com/office/drawing/2014/main" id="{D8A800EB-B234-2C9E-1AC0-870E1FAC85FC}"/>
+                </a:ext>
+              </a:extLst>
+            </p:cNvPr>
+            <p:cNvCxnSpPr>
+              <a:cxnSpLocks/>
+            </p:cNvCxnSpPr>
+            <p:nvPr/>
+          </p:nvCxnSpPr>
+          <p:spPr>
+            <a:xfrm>
+              <a:off x="4363278" y="356260"/>
+              <a:ext cx="0" cy="3437205"/>
+            </a:xfrm>
+            <a:prstGeom prst="line">
+              <a:avLst/>
+            </a:prstGeom>
+            <a:ln w="12700">
+              <a:solidFill>
+                <a:schemeClr val="tx1"/>
+              </a:solidFill>
+              <a:prstDash val="dashDot"/>
+            </a:ln>
+          </p:spPr>
+          <p:style>
+            <a:lnRef idx="2">
+              <a:schemeClr val="accent1"/>
+            </a:lnRef>
+            <a:fillRef idx="0">
+              <a:schemeClr val="accent1"/>
+            </a:fillRef>
+            <a:effectRef idx="1">
+              <a:schemeClr val="accent1"/>
+            </a:effectRef>
+            <a:fontRef idx="minor">
+              <a:schemeClr val="tx1"/>
+            </a:fontRef>
+          </p:style>
+        </p:cxnSp>
+        <p:grpSp>
+          <p:nvGrpSpPr>
+            <p:cNvPr id="13" name="Group 12">
+              <a:extLst>
+                <a:ext uri="{FF2B5EF4-FFF2-40B4-BE49-F238E27FC236}">
+                  <a16:creationId xmlns:a16="http://schemas.microsoft.com/office/drawing/2014/main" id="{E6E3C942-C13E-6973-E60C-B3F8F3E73501}"/>
+                </a:ext>
+              </a:extLst>
+            </p:cNvPr>
+            <p:cNvGrpSpPr/>
+            <p:nvPr/>
+          </p:nvGrpSpPr>
+          <p:grpSpPr>
+            <a:xfrm>
+              <a:off x="3841372" y="820398"/>
+              <a:ext cx="381836" cy="621200"/>
+              <a:chOff x="4484618" y="1089124"/>
+              <a:chExt cx="381836" cy="978212"/>
+            </a:xfrm>
+          </p:grpSpPr>
+          <p:cxnSp>
+            <p:nvCxnSpPr>
+              <p:cNvPr id="18" name="Straight Arrow Connector 17">
+                <a:extLst>
+                  <a:ext uri="{FF2B5EF4-FFF2-40B4-BE49-F238E27FC236}">
+                    <a16:creationId xmlns:a16="http://schemas.microsoft.com/office/drawing/2014/main" id="{C2F73665-3BD3-F5B1-2FB8-77427E20091F}"/>
+                  </a:ext>
+                </a:extLst>
+              </p:cNvPr>
+              <p:cNvCxnSpPr/>
+              <p:nvPr/>
+            </p:nvCxnSpPr>
+            <p:spPr>
+              <a:xfrm>
+                <a:off x="4648285" y="1421293"/>
+                <a:ext cx="0" cy="646043"/>
+              </a:xfrm>
+              <a:prstGeom prst="straightConnector1">
+                <a:avLst/>
+              </a:prstGeom>
+              <a:ln>
+                <a:tailEnd type="triangle"/>
+              </a:ln>
+            </p:spPr>
+            <p:style>
+              <a:lnRef idx="2">
+                <a:schemeClr val="accent1"/>
+              </a:lnRef>
+              <a:fillRef idx="0">
+                <a:schemeClr val="accent1"/>
+              </a:fillRef>
+              <a:effectRef idx="1">
+                <a:schemeClr val="accent1"/>
+              </a:effectRef>
+              <a:fontRef idx="minor">
+                <a:schemeClr val="tx1"/>
+              </a:fontRef>
+            </p:style>
+          </p:cxnSp>
+          <p:sp>
+            <p:nvSpPr>
+              <p:cNvPr id="20" name="TextBox 19">
+                <a:extLst>
+                  <a:ext uri="{FF2B5EF4-FFF2-40B4-BE49-F238E27FC236}">
+                    <a16:creationId xmlns:a16="http://schemas.microsoft.com/office/drawing/2014/main" id="{929C312E-CE1D-83AA-F3F8-8DBB0A9B2D1E}"/>
+                  </a:ext>
+                </a:extLst>
+              </p:cNvPr>
+              <p:cNvSpPr txBox="1"/>
+              <p:nvPr/>
+            </p:nvSpPr>
+            <p:spPr>
+              <a:xfrm>
+                <a:off x="4484618" y="1089124"/>
+                <a:ext cx="381836" cy="369332"/>
+              </a:xfrm>
+              <a:prstGeom prst="rect">
+                <a:avLst/>
+              </a:prstGeom>
+              <a:solidFill>
+                <a:schemeClr val="bg1"/>
+              </a:solidFill>
+            </p:spPr>
+            <p:txBody>
+              <a:bodyPr wrap="none" rtlCol="0">
+                <a:spAutoFit/>
+              </a:bodyPr>
+              <a:lstStyle/>
+              <a:p>
+                <a:r>
+                  <a:rPr lang="en-US" i="1" dirty="0"/>
+                  <a:t>q</a:t>
+                </a:r>
+                <a:r>
+                  <a:rPr lang="en-US" i="1" baseline="-25000" dirty="0"/>
+                  <a:t>0</a:t>
+                </a:r>
+              </a:p>
+            </p:txBody>
+          </p:sp>
+        </p:grpSp>
+        <p:cxnSp>
+          <p:nvCxnSpPr>
+            <p:cNvPr id="29" name="Straight Connector 28">
+              <a:extLst>
+                <a:ext uri="{FF2B5EF4-FFF2-40B4-BE49-F238E27FC236}">
+                  <a16:creationId xmlns:a16="http://schemas.microsoft.com/office/drawing/2014/main" id="{6DDF2CE7-AE5F-27FE-5250-5BD9999AE671}"/>
+                </a:ext>
+              </a:extLst>
+            </p:cNvPr>
+            <p:cNvCxnSpPr>
+              <a:cxnSpLocks/>
+            </p:cNvCxnSpPr>
+            <p:nvPr/>
+          </p:nvCxnSpPr>
+          <p:spPr>
+            <a:xfrm>
+              <a:off x="5136551" y="4161074"/>
+              <a:ext cx="1958009" cy="0"/>
+            </a:xfrm>
+            <a:prstGeom prst="line">
+              <a:avLst/>
+            </a:prstGeom>
+          </p:spPr>
+          <p:style>
+            <a:lnRef idx="2">
+              <a:schemeClr val="accent1"/>
+            </a:lnRef>
+            <a:fillRef idx="0">
+              <a:schemeClr val="accent1"/>
+            </a:fillRef>
+            <a:effectRef idx="1">
+              <a:schemeClr val="accent1"/>
+            </a:effectRef>
+            <a:fontRef idx="minor">
+              <a:schemeClr val="tx1"/>
+            </a:fontRef>
+          </p:style>
+        </p:cxnSp>
+        <p:cxnSp>
+          <p:nvCxnSpPr>
+            <p:cNvPr id="31" name="Straight Connector 30">
+              <a:extLst>
+                <a:ext uri="{FF2B5EF4-FFF2-40B4-BE49-F238E27FC236}">
+                  <a16:creationId xmlns:a16="http://schemas.microsoft.com/office/drawing/2014/main" id="{44F9E341-D9B4-D877-5874-929CC654B590}"/>
+                </a:ext>
+              </a:extLst>
+            </p:cNvPr>
+            <p:cNvCxnSpPr>
+              <a:cxnSpLocks/>
+            </p:cNvCxnSpPr>
+            <p:nvPr/>
+          </p:nvCxnSpPr>
+          <p:spPr>
+            <a:xfrm>
+              <a:off x="1608160" y="5940974"/>
+              <a:ext cx="5486400" cy="0"/>
+            </a:xfrm>
+            <a:prstGeom prst="line">
+              <a:avLst/>
+            </a:prstGeom>
+          </p:spPr>
+          <p:style>
+            <a:lnRef idx="2">
+              <a:schemeClr val="accent1"/>
+            </a:lnRef>
+            <a:fillRef idx="0">
+              <a:schemeClr val="accent1"/>
+            </a:fillRef>
+            <a:effectRef idx="1">
+              <a:schemeClr val="accent1"/>
+            </a:effectRef>
+            <a:fontRef idx="minor">
+              <a:schemeClr val="tx1"/>
+            </a:fontRef>
+          </p:style>
+        </p:cxnSp>
+        <p:sp>
+          <p:nvSpPr>
+            <p:cNvPr id="34" name="Freeform 33">
+              <a:extLst>
+                <a:ext uri="{FF2B5EF4-FFF2-40B4-BE49-F238E27FC236}">
+                  <a16:creationId xmlns:a16="http://schemas.microsoft.com/office/drawing/2014/main" id="{CDEF371F-097A-8CA1-81FA-802F77DE7E82}"/>
+                </a:ext>
+              </a:extLst>
+            </p:cNvPr>
+            <p:cNvSpPr/>
+            <p:nvPr/>
+          </p:nvSpPr>
+          <p:spPr>
+            <a:xfrm>
+              <a:off x="5126612" y="4262060"/>
+              <a:ext cx="1997766" cy="82052"/>
+            </a:xfrm>
+            <a:custGeom>
+              <a:avLst/>
+              <a:gdLst>
+                <a:gd name="csX0" fmla="*/ 0 w 1997766"/>
+                <a:gd name="csY0" fmla="*/ 0 h 437322"/>
+                <a:gd name="csX1" fmla="*/ 854766 w 1997766"/>
+                <a:gd name="csY1" fmla="*/ 437322 h 437322"/>
+                <a:gd name="csX2" fmla="*/ 1997766 w 1997766"/>
+                <a:gd name="csY2" fmla="*/ 268357 h 437322"/>
+                <a:gd name="csX0" fmla="*/ 0 w 1997766"/>
+                <a:gd name="csY0" fmla="*/ 0 h 285851"/>
+                <a:gd name="csX1" fmla="*/ 775253 w 1997766"/>
+                <a:gd name="csY1" fmla="*/ 278296 h 285851"/>
+                <a:gd name="csX2" fmla="*/ 1997766 w 1997766"/>
+                <a:gd name="csY2" fmla="*/ 268357 h 285851"/>
+                <a:gd name="csX0" fmla="*/ 0 w 1997766"/>
+                <a:gd name="csY0" fmla="*/ 0 h 268357"/>
+                <a:gd name="csX1" fmla="*/ 1997766 w 1997766"/>
+                <a:gd name="csY1" fmla="*/ 268357 h 268357"/>
+                <a:gd name="csX0" fmla="*/ 0 w 1997766"/>
+                <a:gd name="csY0" fmla="*/ 0 h 268357"/>
+                <a:gd name="csX1" fmla="*/ 1997766 w 1997766"/>
+                <a:gd name="csY1" fmla="*/ 268357 h 268357"/>
+                <a:gd name="csX0" fmla="*/ 0 w 1997766"/>
+                <a:gd name="csY0" fmla="*/ 0 h 129209"/>
+                <a:gd name="csX1" fmla="*/ 1997766 w 1997766"/>
+                <a:gd name="csY1" fmla="*/ 129209 h 129209"/>
+                <a:gd name="csX0" fmla="*/ 0 w 1997766"/>
+                <a:gd name="csY0" fmla="*/ 0 h 129209"/>
+                <a:gd name="csX1" fmla="*/ 1997766 w 1997766"/>
+                <a:gd name="csY1" fmla="*/ 129209 h 129209"/>
+              </a:gdLst>
+              <a:ahLst/>
+              <a:cxnLst>
+                <a:cxn ang="0">
+                  <a:pos x="csX0" y="csY0"/>
+                </a:cxn>
+                <a:cxn ang="0">
+                  <a:pos x="csX1" y="csY1"/>
+                </a:cxn>
+              </a:cxnLst>
+              <a:rect l="l" t="t" r="r" b="b"/>
+              <a:pathLst>
+                <a:path w="1997766" h="129209">
+                  <a:moveTo>
+                    <a:pt x="0" y="0"/>
+                  </a:moveTo>
+                  <a:cubicBezTo>
+                    <a:pt x="616227" y="89452"/>
+                    <a:pt x="805070" y="119270"/>
+                    <a:pt x="1997766" y="129209"/>
+                  </a:cubicBezTo>
+                </a:path>
+              </a:pathLst>
+            </a:custGeom>
+            <a:noFill/>
+          </p:spPr>
+          <p:style>
+            <a:lnRef idx="1">
+              <a:schemeClr val="accent1"/>
+            </a:lnRef>
+            <a:fillRef idx="3">
+              <a:schemeClr val="accent1"/>
+            </a:fillRef>
+            <a:effectRef idx="2">
+              <a:schemeClr val="accent1"/>
+            </a:effectRef>
+            <a:fontRef idx="minor">
+              <a:schemeClr val="lt1"/>
+            </a:fontRef>
+          </p:style>
+          <p:txBody>
+            <a:bodyPr rtlCol="0" anchor="ctr"/>
+            <a:lstStyle/>
+            <a:p>
+              <a:pPr algn="ctr"/>
+              <a:endParaRPr lang="en-US" dirty="0"/>
+            </a:p>
+          </p:txBody>
+        </p:sp>
+        <p:grpSp>
+          <p:nvGrpSpPr>
+            <p:cNvPr id="47" name="Group 46">
+              <a:extLst>
+                <a:ext uri="{FF2B5EF4-FFF2-40B4-BE49-F238E27FC236}">
+                  <a16:creationId xmlns:a16="http://schemas.microsoft.com/office/drawing/2014/main" id="{56F0F23B-75C7-7F22-506E-F691CF6379CE}"/>
+                </a:ext>
+              </a:extLst>
+            </p:cNvPr>
+            <p:cNvGrpSpPr/>
+            <p:nvPr/>
+          </p:nvGrpSpPr>
+          <p:grpSpPr>
+            <a:xfrm>
+              <a:off x="6944827" y="4344113"/>
+              <a:ext cx="327334" cy="1596862"/>
+              <a:chOff x="6339187" y="4344113"/>
+              <a:chExt cx="327334" cy="1596862"/>
+            </a:xfrm>
+          </p:grpSpPr>
+          <p:cxnSp>
+            <p:nvCxnSpPr>
+              <p:cNvPr id="36" name="Straight Arrow Connector 35">
+                <a:extLst>
+                  <a:ext uri="{FF2B5EF4-FFF2-40B4-BE49-F238E27FC236}">
+                    <a16:creationId xmlns:a16="http://schemas.microsoft.com/office/drawing/2014/main" id="{2F035C81-7435-9F8C-54F0-F5FDE31105D3}"/>
+                  </a:ext>
+                </a:extLst>
+              </p:cNvPr>
+              <p:cNvCxnSpPr>
+                <a:cxnSpLocks/>
+              </p:cNvCxnSpPr>
+              <p:nvPr/>
+            </p:nvCxnSpPr>
+            <p:spPr>
+              <a:xfrm>
+                <a:off x="6478334" y="4344113"/>
+                <a:ext cx="0" cy="1596862"/>
+              </a:xfrm>
+              <a:prstGeom prst="straightConnector1">
+                <a:avLst/>
+              </a:prstGeom>
+              <a:ln w="12700">
+                <a:headEnd type="triangle"/>
+                <a:tailEnd type="triangle"/>
+              </a:ln>
+            </p:spPr>
+            <p:style>
+              <a:lnRef idx="2">
+                <a:schemeClr val="accent1"/>
+              </a:lnRef>
+              <a:fillRef idx="0">
+                <a:schemeClr val="accent1"/>
+              </a:fillRef>
+              <a:effectRef idx="1">
+                <a:schemeClr val="accent1"/>
+              </a:effectRef>
+              <a:fontRef idx="minor">
+                <a:schemeClr val="tx1"/>
+              </a:fontRef>
+            </p:style>
+          </p:cxnSp>
+          <p:sp>
+            <p:nvSpPr>
+              <p:cNvPr id="37" name="TextBox 36">
+                <a:extLst>
+                  <a:ext uri="{FF2B5EF4-FFF2-40B4-BE49-F238E27FC236}">
+                    <a16:creationId xmlns:a16="http://schemas.microsoft.com/office/drawing/2014/main" id="{1A6341E3-8532-2E53-D33B-8A04EBCADFD5}"/>
+                  </a:ext>
+                </a:extLst>
+              </p:cNvPr>
+              <p:cNvSpPr txBox="1"/>
+              <p:nvPr/>
+            </p:nvSpPr>
+            <p:spPr>
+              <a:xfrm>
+                <a:off x="6339187" y="4950037"/>
+                <a:ext cx="327334" cy="234539"/>
+              </a:xfrm>
+              <a:prstGeom prst="rect">
+                <a:avLst/>
+              </a:prstGeom>
+              <a:solidFill>
+                <a:schemeClr val="bg1"/>
+              </a:solidFill>
+            </p:spPr>
+            <p:txBody>
+              <a:bodyPr wrap="none" rtlCol="0">
+                <a:spAutoFit/>
+              </a:bodyPr>
+              <a:lstStyle/>
+              <a:p>
+                <a:r>
+                  <a:rPr lang="en-US" i="1" dirty="0"/>
+                  <a:t>D</a:t>
+                </a:r>
+              </a:p>
+            </p:txBody>
+          </p:sp>
+        </p:grpSp>
+        <p:grpSp>
+          <p:nvGrpSpPr>
+            <p:cNvPr id="38" name="Group 37">
+              <a:extLst>
+                <a:ext uri="{FF2B5EF4-FFF2-40B4-BE49-F238E27FC236}">
+                  <a16:creationId xmlns:a16="http://schemas.microsoft.com/office/drawing/2014/main" id="{393814F4-39D5-D727-94BC-A9399369657C}"/>
+                </a:ext>
+              </a:extLst>
+            </p:cNvPr>
+            <p:cNvGrpSpPr/>
+            <p:nvPr/>
+          </p:nvGrpSpPr>
+          <p:grpSpPr>
+            <a:xfrm>
+              <a:off x="4482639" y="3527249"/>
+              <a:ext cx="381836" cy="621200"/>
+              <a:chOff x="4484618" y="1089124"/>
+              <a:chExt cx="381836" cy="978212"/>
+            </a:xfrm>
+          </p:grpSpPr>
+          <p:cxnSp>
+            <p:nvCxnSpPr>
+              <p:cNvPr id="39" name="Straight Arrow Connector 38">
+                <a:extLst>
+                  <a:ext uri="{FF2B5EF4-FFF2-40B4-BE49-F238E27FC236}">
+                    <a16:creationId xmlns:a16="http://schemas.microsoft.com/office/drawing/2014/main" id="{E0C49275-E7D7-18BF-5AB9-0D69F9308836}"/>
+                  </a:ext>
+                </a:extLst>
+              </p:cNvPr>
+              <p:cNvCxnSpPr/>
+              <p:nvPr/>
+            </p:nvCxnSpPr>
+            <p:spPr>
+              <a:xfrm>
+                <a:off x="4648285" y="1421293"/>
+                <a:ext cx="0" cy="646043"/>
+              </a:xfrm>
+              <a:prstGeom prst="straightConnector1">
+                <a:avLst/>
+              </a:prstGeom>
+              <a:ln>
+                <a:tailEnd type="triangle"/>
+              </a:ln>
+            </p:spPr>
+            <p:style>
+              <a:lnRef idx="2">
+                <a:schemeClr val="accent1"/>
+              </a:lnRef>
+              <a:fillRef idx="0">
+                <a:schemeClr val="accent1"/>
+              </a:fillRef>
+              <a:effectRef idx="1">
+                <a:schemeClr val="accent1"/>
+              </a:effectRef>
+              <a:fontRef idx="minor">
+                <a:schemeClr val="tx1"/>
+              </a:fontRef>
+            </p:style>
+          </p:cxnSp>
+          <p:sp>
+            <p:nvSpPr>
+              <p:cNvPr id="40" name="TextBox 39">
+                <a:extLst>
+                  <a:ext uri="{FF2B5EF4-FFF2-40B4-BE49-F238E27FC236}">
+                    <a16:creationId xmlns:a16="http://schemas.microsoft.com/office/drawing/2014/main" id="{5BE6C08C-CF0F-816B-7B01-70CC83B08E61}"/>
+                  </a:ext>
+                </a:extLst>
+              </p:cNvPr>
+              <p:cNvSpPr txBox="1"/>
+              <p:nvPr/>
+            </p:nvSpPr>
+            <p:spPr>
+              <a:xfrm>
+                <a:off x="4484618" y="1089124"/>
+                <a:ext cx="381836" cy="369332"/>
+              </a:xfrm>
+              <a:prstGeom prst="rect">
+                <a:avLst/>
+              </a:prstGeom>
+              <a:solidFill>
+                <a:schemeClr val="bg1"/>
+              </a:solidFill>
+            </p:spPr>
+            <p:txBody>
+              <a:bodyPr wrap="none" rtlCol="0">
+                <a:spAutoFit/>
+              </a:bodyPr>
+              <a:lstStyle/>
+              <a:p>
+                <a:r>
+                  <a:rPr lang="en-US" i="1" dirty="0"/>
+                  <a:t>q</a:t>
+                </a:r>
+                <a:r>
+                  <a:rPr lang="en-US" i="1" baseline="-25000" dirty="0"/>
+                  <a:t>0</a:t>
+                </a:r>
+              </a:p>
+            </p:txBody>
+          </p:sp>
+        </p:grpSp>
+        <p:sp>
+          <p:nvSpPr>
+            <p:cNvPr id="44" name="Rectangle 43">
+              <a:extLst>
+                <a:ext uri="{FF2B5EF4-FFF2-40B4-BE49-F238E27FC236}">
+                  <a16:creationId xmlns:a16="http://schemas.microsoft.com/office/drawing/2014/main" id="{8A7199E0-963B-F18F-5C8D-0A6BCAA5CF18}"/>
+                </a:ext>
+              </a:extLst>
+            </p:cNvPr>
+            <p:cNvSpPr/>
+            <p:nvPr/>
+          </p:nvSpPr>
+          <p:spPr>
+            <a:xfrm>
+              <a:off x="5112801" y="4262060"/>
+              <a:ext cx="66263" cy="1678914"/>
+            </a:xfrm>
+            <a:prstGeom prst="rect">
+              <a:avLst/>
+            </a:prstGeom>
+            <a:solidFill>
+              <a:srgbClr val="C00000"/>
+            </a:solidFill>
+          </p:spPr>
+          <p:style>
+            <a:lnRef idx="1">
+              <a:schemeClr val="accent1"/>
+            </a:lnRef>
+            <a:fillRef idx="3">
+              <a:schemeClr val="accent1"/>
+            </a:fillRef>
+            <a:effectRef idx="2">
+              <a:schemeClr val="accent1"/>
+            </a:effectRef>
+            <a:fontRef idx="minor">
+              <a:schemeClr val="lt1"/>
+            </a:fontRef>
+          </p:style>
+          <p:txBody>
+            <a:bodyPr rtlCol="0" anchor="ctr"/>
+            <a:lstStyle/>
+            <a:p>
+              <a:pPr algn="ctr"/>
+              <a:endParaRPr lang="en-US" dirty="0"/>
+            </a:p>
+          </p:txBody>
+        </p:sp>
+        <p:sp>
+          <p:nvSpPr>
+            <p:cNvPr id="45" name="Rectangle 44">
+              <a:extLst>
+                <a:ext uri="{FF2B5EF4-FFF2-40B4-BE49-F238E27FC236}">
+                  <a16:creationId xmlns:a16="http://schemas.microsoft.com/office/drawing/2014/main" id="{4347AED4-956F-F361-A27D-5C8C2237E72A}"/>
+                </a:ext>
+              </a:extLst>
+            </p:cNvPr>
+            <p:cNvSpPr/>
+            <p:nvPr/>
+          </p:nvSpPr>
+          <p:spPr>
+            <a:xfrm>
+              <a:off x="2368502" y="4246891"/>
+              <a:ext cx="2763080" cy="1679932"/>
+            </a:xfrm>
+            <a:prstGeom prst="rect">
+              <a:avLst/>
+            </a:prstGeom>
+            <a:solidFill>
+              <a:srgbClr val="00B0F0">
+                <a:alpha val="71000"/>
+              </a:srgbClr>
+            </a:solidFill>
+            <a:ln>
+              <a:noFill/>
+            </a:ln>
+          </p:spPr>
+          <p:style>
+            <a:lnRef idx="1">
+              <a:schemeClr val="accent1"/>
+            </a:lnRef>
+            <a:fillRef idx="3">
+              <a:schemeClr val="accent1"/>
+            </a:fillRef>
+            <a:effectRef idx="2">
+              <a:schemeClr val="accent1"/>
+            </a:effectRef>
+            <a:fontRef idx="minor">
+              <a:schemeClr val="lt1"/>
+            </a:fontRef>
+          </p:style>
+          <p:txBody>
+            <a:bodyPr rtlCol="0" anchor="ctr"/>
+            <a:lstStyle/>
+            <a:p>
+              <a:pPr algn="ctr"/>
+              <a:r>
+                <a:rPr lang="en-US" dirty="0" err="1"/>
+                <a:t>Volkomen</a:t>
+              </a:r>
+              <a:r>
+                <a:rPr lang="en-US" dirty="0"/>
+                <a:t> </a:t>
+              </a:r>
+              <a:r>
+                <a:rPr lang="en-US" dirty="0" err="1"/>
+                <a:t>sloot</a:t>
+              </a:r>
+              <a:endParaRPr lang="en-US" dirty="0"/>
+            </a:p>
+          </p:txBody>
+        </p:sp>
+        <p:sp>
+          <p:nvSpPr>
+            <p:cNvPr id="46" name="Rectangular Callout 45">
+              <a:extLst>
+                <a:ext uri="{FF2B5EF4-FFF2-40B4-BE49-F238E27FC236}">
+                  <a16:creationId xmlns:a16="http://schemas.microsoft.com/office/drawing/2014/main" id="{1F7BE308-7321-4161-1AB5-E305FDAF71B1}"/>
+                </a:ext>
+              </a:extLst>
+            </p:cNvPr>
+            <p:cNvSpPr/>
+            <p:nvPr/>
+          </p:nvSpPr>
+          <p:spPr>
+            <a:xfrm>
+              <a:off x="5302608" y="4450751"/>
+              <a:ext cx="1465978" cy="612628"/>
+            </a:xfrm>
+            <a:prstGeom prst="wedgeRectCallout">
+              <a:avLst>
+                <a:gd name="adj1" fmla="val -61336"/>
+                <a:gd name="adj2" fmla="val 110960"/>
+              </a:avLst>
+            </a:prstGeom>
+            <a:solidFill>
+              <a:srgbClr val="002060"/>
+            </a:solidFill>
+          </p:spPr>
+          <p:style>
+            <a:lnRef idx="1">
+              <a:schemeClr val="accent1"/>
+            </a:lnRef>
+            <a:fillRef idx="3">
+              <a:schemeClr val="accent1"/>
+            </a:fillRef>
+            <a:effectRef idx="2">
+              <a:schemeClr val="accent1"/>
+            </a:effectRef>
+            <a:fontRef idx="minor">
+              <a:schemeClr val="lt1"/>
+            </a:fontRef>
+          </p:style>
+          <p:txBody>
+            <a:bodyPr rtlCol="0" anchor="ctr"/>
+            <a:lstStyle/>
+            <a:p>
+              <a:pPr algn="ctr"/>
+              <a:r>
+                <a:rPr lang="en-US" sz="1400" dirty="0" err="1"/>
+                <a:t>Muurtje</a:t>
+              </a:r>
+              <a:r>
+                <a:rPr lang="en-US" sz="1400" dirty="0"/>
+                <a:t> met </a:t>
+              </a:r>
+              <a:r>
+                <a:rPr lang="en-US" sz="1400" dirty="0" err="1"/>
+                <a:t>weerstand</a:t>
+              </a:r>
+              <a:r>
+                <a:rPr lang="en-US" sz="1400" dirty="0"/>
+                <a:t> w</a:t>
+              </a:r>
+            </a:p>
+          </p:txBody>
+        </p:sp>
+        <p:sp>
+          <p:nvSpPr>
+            <p:cNvPr id="48" name="Rectangular Callout 47">
+              <a:extLst>
+                <a:ext uri="{FF2B5EF4-FFF2-40B4-BE49-F238E27FC236}">
+                  <a16:creationId xmlns:a16="http://schemas.microsoft.com/office/drawing/2014/main" id="{3524ACC8-1E8A-1D88-6AB1-B58482F96001}"/>
+                </a:ext>
+              </a:extLst>
+            </p:cNvPr>
+            <p:cNvSpPr/>
+            <p:nvPr/>
+          </p:nvSpPr>
+          <p:spPr>
+            <a:xfrm>
+              <a:off x="1716400" y="2161125"/>
+              <a:ext cx="1465978" cy="612628"/>
+            </a:xfrm>
+            <a:prstGeom prst="wedgeRectCallout">
+              <a:avLst>
+                <a:gd name="adj1" fmla="val 115257"/>
+                <a:gd name="adj2" fmla="val -129404"/>
+              </a:avLst>
+            </a:prstGeom>
+            <a:solidFill>
+              <a:srgbClr val="002060"/>
+            </a:solidFill>
+          </p:spPr>
+          <p:style>
+            <a:lnRef idx="1">
+              <a:schemeClr val="accent1"/>
+            </a:lnRef>
+            <a:fillRef idx="3">
+              <a:schemeClr val="accent1"/>
+            </a:fillRef>
+            <a:effectRef idx="2">
+              <a:schemeClr val="accent1"/>
+            </a:effectRef>
+            <a:fontRef idx="minor">
+              <a:schemeClr val="lt1"/>
+            </a:fontRef>
+          </p:style>
+          <p:txBody>
+            <a:bodyPr rtlCol="0" anchor="ctr"/>
+            <a:lstStyle/>
+            <a:p>
+              <a:pPr algn="ctr"/>
+              <a:r>
+                <a:rPr lang="en-US" sz="1400" dirty="0" err="1"/>
+                <a:t>Onvolkomen</a:t>
+              </a:r>
+              <a:r>
+                <a:rPr lang="en-US" sz="1400" dirty="0"/>
+                <a:t> </a:t>
+              </a:r>
+              <a:r>
+                <a:rPr lang="en-US" sz="1400" dirty="0" err="1"/>
+                <a:t>sloot</a:t>
+              </a:r>
+              <a:endParaRPr lang="en-US" sz="1400" dirty="0"/>
+            </a:p>
+          </p:txBody>
+        </p:sp>
+      </p:grpSp>
+    </p:spTree>
+    <p:extLst>
+      <p:ext uri="{BB962C8B-B14F-4D97-AF65-F5344CB8AC3E}">
+        <p14:creationId xmlns:p14="http://schemas.microsoft.com/office/powerpoint/2010/main" val="731137751"/>
+      </p:ext>
+    </p:extLst>
+  </p:cSld>
+  <p:clrMapOvr>
+    <a:masterClrMapping/>
+  </p:clrMapOvr>
+</p:sld>
+</file>
+
+<file path=ppt/slides/slide6.xml><?xml version="1.0" encoding="utf-8"?>
+<p:sld xmlns:a="http://schemas.openxmlformats.org/drawingml/2006/main" xmlns:r="http://schemas.openxmlformats.org/officeDocument/2006/relationships" xmlns:p="http://schemas.openxmlformats.org/presentationml/2006/main">
+  <p:cSld>
+    <p:spTree>
+      <p:nvGrpSpPr>
         <p:cNvPr id="1" name=""/>
         <p:cNvGrpSpPr/>
         <p:nvPr/>
@@ -5831,7 +8154,7 @@
 </p:sld>
 </file>
 
-<file path=ppt/slides/slide6.xml><?xml version="1.0" encoding="utf-8"?>
+<file path=ppt/slides/slide7.xml><?xml version="1.0" encoding="utf-8"?>
 <p:sld xmlns:a="http://schemas.openxmlformats.org/drawingml/2006/main" xmlns:r="http://schemas.openxmlformats.org/officeDocument/2006/relationships" xmlns:p="http://schemas.openxmlformats.org/presentationml/2006/main">
   <p:cSld>
     <p:spTree>
@@ -5885,7 +8208,7 @@
 </p:sld>
 </file>
 
-<file path=ppt/slides/slide7.xml><?xml version="1.0" encoding="utf-8"?>
+<file path=ppt/slides/slide8.xml><?xml version="1.0" encoding="utf-8"?>
 <p:sld xmlns:a="http://schemas.openxmlformats.org/drawingml/2006/main" xmlns:r="http://schemas.openxmlformats.org/officeDocument/2006/relationships" xmlns:p="http://schemas.openxmlformats.org/presentationml/2006/main">
   <p:cSld>
     <p:spTree>

</xml_diff>